<commit_message>
Day3 g1_crispr: polish deck — fill sparse cards, center stat tiles, divider notes
</commit_message>
<xml_diff>
--- a/solutions/g1_crispr/slides/g1_crispr.pptx
+++ b/solutions/g1_crispr/slides/g1_crispr.pptx
@@ -7,7 +7,7 @@
   <p:sldIdLst>
     <p:sldId id="256" r:id="rId7"/>
     <p:sldId id="257" r:id="rId8"/>
-    <p:sldId id="258" r:id="rId9"/>
+    <p:sldId id="258" r:id="rId10"/>
     <p:sldId id="259" r:id="rId11"/>
     <p:sldId id="260" r:id="rId12"/>
     <p:sldId id="261" r:id="rId13"/>
@@ -522,7 +522,7 @@
               <a:rPr b="1" sz="1300">
                 <a:latin typeface="Geist Mono"/>
               </a:rPr>
-              <a:t>What CRISPR actually is</a:t>
+              <a:t>Background</a:t>
             </a:r>
           </a:p>
           <a:p>
@@ -530,11 +530,7 @@
               <a:rPr b="0" sz="1100">
                 <a:latin typeface="Geist"/>
               </a:rPr>
-              <a:t>Open concrete and physical. CRISPR-Cas9 is scissors plus a 20-letter address label. Point at the
-figure: the turquoise block is the guide/protospacer, the pink block just to its right is the PAM
-(always NGG), and Cas9 snips a few letters upstream. Every guide in our dataset is one of these
-20-letter strings. Do not mention machine learning yet -- just make sure they can read the picture.
-Transition: so how do real scientists decide which 20 letters to use?</a:t>
+              <a:t>We open with the biology so the modeling lands later. Three ideas to plant here: CRISPR is a 20-letter guided cut, real scientists SCORE a guide from its sequence instead of testing every one, and the seed region next to the PAM matters most. Transition: let's start with what a guide actually is.</a:t>
             </a:r>
           </a:p>
         </p:txBody>
@@ -607,7 +603,7 @@
               <a:rPr b="1" sz="1300">
                 <a:latin typeface="Geist Mono"/>
               </a:rPr>
-              <a:t>What this toy model can and cannot do</a:t>
+              <a:t>Why we grade with AUC, not accuracy</a:t>
             </a:r>
           </a:p>
           <a:p>
@@ -615,11 +611,11 @@
               <a:rPr b="0" sz="1100">
                 <a:latin typeface="Geist"/>
               </a:rPr>
-              <a:t>Model the intellectual honesty the rubric rewards. Green light: it genuinely shows sequence carries
-signal and the seed matters, on the pros' own data [1]. Red lights: it will not beat a production tool
-and cannot see cell-type or chromatin effects [7]; and crucially it says NOTHING about off-target
-safety [8] -- the single most important question for real CRISPR use. State plainly: this builds
-intuition, it does not choose a clinical guide. Transition: the papers, then the bottom line.</a:t>
+              <a:t>The judgment slide. On imbalanced data accuracy lies: an 'always low' model scores 80 percent and is
+worthless because it never flags a usable guide. AUC sidesteps the trick -- it measures whether the
+model RANKS good guides above bad ones, so 0.5 is a coin flip and 1.0 is perfect. Our 0.77 means real
+ranking skill. This same trap (accuracy on imbalanced data) shows up everywhere in medical AI, so it
+is worth over-teaching. Transition: now the most satisfying result.</a:t>
             </a:r>
           </a:p>
         </p:txBody>
@@ -692,7 +688,7 @@
               <a:rPr b="1" sz="1300">
                 <a:latin typeface="Geist Mono"/>
               </a:rPr>
-              <a:t>References</a:t>
+              <a:t>The model rediscovered the seed</a:t>
             </a:r>
           </a:p>
           <a:p>
@@ -700,11 +696,12 @@
               <a:rPr b="0" sz="1100">
                 <a:latin typeface="Geist"/>
               </a:rPr>
-              <a:t>Give credit and show the trail. Left column is the foundation: the two Doench Rule Sets [1][2], the
-Hsu/Lander/Zhang review [3], and the Zheng seed paper [4]. Right column is the modern neural-net line
-and the surveys [5][6][7][8]. Do not read every line -- point out that [1] gave us the data, [4] is
-the seed evidence our model reproduced, and [8] is the off-target-safety gap we cannot address.
-Transition: the one sentence to remember.</a:t>
+              <a:t>The wow moment -- put it up and pause. We asked a plain logistic-regression model which of the 20
+positions it relied on, and the importance peaks at position 20, right at the PAM: the seed. Flip back
+to the background seed chart -- same shape. Nobody encoded that; the model recovered decades of CRISPR
+biology from sequences and cut-scores alone. Tie it to trust: an explainable model that matches known
+science is one clinicians and biologists will believe. Transition: can it predict the exact score,
+not just high vs low?</a:t>
             </a:r>
           </a:p>
         </p:txBody>
@@ -777,6 +774,342 @@
               <a:rPr b="1" sz="1300">
                 <a:latin typeface="Geist Mono"/>
               </a:rPr>
+              <a:t>Predicting the exact score</a:t>
+            </a:r>
+          </a:p>
+          <a:p>
+            <a:r>
+              <a:rPr b="0" sz="1100">
+                <a:latin typeface="Geist"/>
+              </a:rPr>
+              <a:t>Second, harder task: predict the exact 0-to-1 score, not just a yes/no. Explain R-squared plainly --
+the fraction of the real variation the model captures, 0 is guessing the mean, 1 is perfect. We get
+0.36 (correlation 0.61): a real but loose trend, visible as a tilted cloud around the diagonal. The
+honest point: the professional predicted-vs-measured plots scatter just like ours [1][5][6]. Useful
+does not mean perfect. Transition: so let's be clear-eyed about what this toy can and cannot do.</a:t>
+            </a:r>
+          </a:p>
+        </p:txBody>
+      </p:sp>
+      <p:sp>
+        <p:nvSpPr>
+          <p:cNvPr id="4" name="Slide Number Placeholder 3"/>
+          <p:cNvSpPr>
+            <a:spLocks noGrp="1"/>
+          </p:cNvSpPr>
+          <p:nvPr>
+            <p:ph type="sldNum" idx="5" sz="quarter"/>
+          </p:nvPr>
+        </p:nvSpPr>
+        <p:spPr/>
+      </p:sp>
+    </p:spTree>
+  </p:cSld>
+  <p:clrMapOvr>
+    <a:masterClrMapping/>
+  </p:clrMapOvr>
+</p:notes>
+</file>
+
+<file path=ppt/notesSlides/notesSlide13.xml><?xml version="1.0" encoding="utf-8"?>
+<p:notes xmlns:a="http://schemas.openxmlformats.org/drawingml/2006/main" xmlns:p="http://schemas.openxmlformats.org/presentationml/2006/main" xmlns:r="http://schemas.openxmlformats.org/officeDocument/2006/relationships">
+  <p:cSld>
+    <p:spTree>
+      <p:nvGrpSpPr>
+        <p:cNvPr id="1" name=""/>
+        <p:cNvGrpSpPr/>
+        <p:nvPr/>
+      </p:nvGrpSpPr>
+      <p:grpSpPr>
+        <a:xfrm>
+          <a:off x="0" y="0"/>
+          <a:ext cx="0" cy="0"/>
+          <a:chOff x="0" y="0"/>
+          <a:chExt cx="0" cy="0"/>
+        </a:xfrm>
+      </p:grpSpPr>
+      <p:sp>
+        <p:nvSpPr>
+          <p:cNvPr id="2" name="Slide Image Placeholder 1"/>
+          <p:cNvSpPr>
+            <a:spLocks noGrp="1"/>
+          </p:cNvSpPr>
+          <p:nvPr>
+            <p:ph type="sldImg" idx="2"/>
+          </p:nvPr>
+        </p:nvSpPr>
+        <p:spPr/>
+      </p:sp>
+      <p:sp>
+        <p:nvSpPr>
+          <p:cNvPr id="3" name="Notes Placeholder 2"/>
+          <p:cNvSpPr>
+            <a:spLocks noGrp="1"/>
+          </p:cNvSpPr>
+          <p:nvPr>
+            <p:ph type="body" idx="3" sz="quarter"/>
+          </p:nvPr>
+        </p:nvSpPr>
+        <p:spPr/>
+        <p:txBody>
+          <a:bodyPr/>
+          <a:lstStyle/>
+          <a:p>
+            <a:r>
+              <a:rPr b="1" sz="1300">
+                <a:latin typeface="Geist Mono"/>
+              </a:rPr>
+              <a:t>Being honest</a:t>
+            </a:r>
+          </a:p>
+          <a:p>
+            <a:r>
+              <a:rPr b="0" sz="1100">
+                <a:latin typeface="Geist"/>
+              </a:rPr>
+              <a:t>Good science states its own limits out loud. We lay out what this toy model genuinely shows, what it cannot do, and the off-target-safety question it says nothing about. Then the references and the one-sentence takeaway. This is the section the rubric rewards most.</a:t>
+            </a:r>
+          </a:p>
+        </p:txBody>
+      </p:sp>
+      <p:sp>
+        <p:nvSpPr>
+          <p:cNvPr id="4" name="Slide Number Placeholder 3"/>
+          <p:cNvSpPr>
+            <a:spLocks noGrp="1"/>
+          </p:cNvSpPr>
+          <p:nvPr>
+            <p:ph type="sldNum" idx="5" sz="quarter"/>
+          </p:nvPr>
+        </p:nvSpPr>
+        <p:spPr/>
+      </p:sp>
+    </p:spTree>
+  </p:cSld>
+  <p:clrMapOvr>
+    <a:masterClrMapping/>
+  </p:clrMapOvr>
+</p:notes>
+</file>
+
+<file path=ppt/notesSlides/notesSlide14.xml><?xml version="1.0" encoding="utf-8"?>
+<p:notes xmlns:a="http://schemas.openxmlformats.org/drawingml/2006/main" xmlns:p="http://schemas.openxmlformats.org/presentationml/2006/main" xmlns:r="http://schemas.openxmlformats.org/officeDocument/2006/relationships">
+  <p:cSld>
+    <p:spTree>
+      <p:nvGrpSpPr>
+        <p:cNvPr id="1" name=""/>
+        <p:cNvGrpSpPr/>
+        <p:nvPr/>
+      </p:nvGrpSpPr>
+      <p:grpSpPr>
+        <a:xfrm>
+          <a:off x="0" y="0"/>
+          <a:ext cx="0" cy="0"/>
+          <a:chOff x="0" y="0"/>
+          <a:chExt cx="0" cy="0"/>
+        </a:xfrm>
+      </p:grpSpPr>
+      <p:sp>
+        <p:nvSpPr>
+          <p:cNvPr id="2" name="Slide Image Placeholder 1"/>
+          <p:cNvSpPr>
+            <a:spLocks noGrp="1"/>
+          </p:cNvSpPr>
+          <p:nvPr>
+            <p:ph type="sldImg" idx="2"/>
+          </p:nvPr>
+        </p:nvSpPr>
+        <p:spPr/>
+      </p:sp>
+      <p:sp>
+        <p:nvSpPr>
+          <p:cNvPr id="3" name="Notes Placeholder 2"/>
+          <p:cNvSpPr>
+            <a:spLocks noGrp="1"/>
+          </p:cNvSpPr>
+          <p:nvPr>
+            <p:ph type="body" idx="3" sz="quarter"/>
+          </p:nvPr>
+        </p:nvSpPr>
+        <p:spPr/>
+        <p:txBody>
+          <a:bodyPr/>
+          <a:lstStyle/>
+          <a:p>
+            <a:r>
+              <a:rPr b="1" sz="1300">
+                <a:latin typeface="Geist Mono"/>
+              </a:rPr>
+              <a:t>What this toy model can and cannot do</a:t>
+            </a:r>
+          </a:p>
+          <a:p>
+            <a:r>
+              <a:rPr b="0" sz="1100">
+                <a:latin typeface="Geist"/>
+              </a:rPr>
+              <a:t>Model the intellectual honesty the rubric rewards. Green light: it genuinely shows sequence carries
+signal and the seed matters, on the pros' own data [1]. Red lights: it will not beat a production tool
+and cannot see cell-type or chromatin effects [7]; and crucially it says NOTHING about off-target
+safety [8] -- the single most important question for real CRISPR use. State plainly: this builds
+intuition, it does not choose a clinical guide. Transition: the papers, then the bottom line.</a:t>
+            </a:r>
+          </a:p>
+        </p:txBody>
+      </p:sp>
+      <p:sp>
+        <p:nvSpPr>
+          <p:cNvPr id="4" name="Slide Number Placeholder 3"/>
+          <p:cNvSpPr>
+            <a:spLocks noGrp="1"/>
+          </p:cNvSpPr>
+          <p:nvPr>
+            <p:ph type="sldNum" idx="5" sz="quarter"/>
+          </p:nvPr>
+        </p:nvSpPr>
+        <p:spPr/>
+      </p:sp>
+    </p:spTree>
+  </p:cSld>
+  <p:clrMapOvr>
+    <a:masterClrMapping/>
+  </p:clrMapOvr>
+</p:notes>
+</file>
+
+<file path=ppt/notesSlides/notesSlide15.xml><?xml version="1.0" encoding="utf-8"?>
+<p:notes xmlns:a="http://schemas.openxmlformats.org/drawingml/2006/main" xmlns:p="http://schemas.openxmlformats.org/presentationml/2006/main" xmlns:r="http://schemas.openxmlformats.org/officeDocument/2006/relationships">
+  <p:cSld>
+    <p:spTree>
+      <p:nvGrpSpPr>
+        <p:cNvPr id="1" name=""/>
+        <p:cNvGrpSpPr/>
+        <p:nvPr/>
+      </p:nvGrpSpPr>
+      <p:grpSpPr>
+        <a:xfrm>
+          <a:off x="0" y="0"/>
+          <a:ext cx="0" cy="0"/>
+          <a:chOff x="0" y="0"/>
+          <a:chExt cx="0" cy="0"/>
+        </a:xfrm>
+      </p:grpSpPr>
+      <p:sp>
+        <p:nvSpPr>
+          <p:cNvPr id="2" name="Slide Image Placeholder 1"/>
+          <p:cNvSpPr>
+            <a:spLocks noGrp="1"/>
+          </p:cNvSpPr>
+          <p:nvPr>
+            <p:ph type="sldImg" idx="2"/>
+          </p:nvPr>
+        </p:nvSpPr>
+        <p:spPr/>
+      </p:sp>
+      <p:sp>
+        <p:nvSpPr>
+          <p:cNvPr id="3" name="Notes Placeholder 2"/>
+          <p:cNvSpPr>
+            <a:spLocks noGrp="1"/>
+          </p:cNvSpPr>
+          <p:nvPr>
+            <p:ph type="body" idx="3" sz="quarter"/>
+          </p:nvPr>
+        </p:nvSpPr>
+        <p:spPr/>
+        <p:txBody>
+          <a:bodyPr/>
+          <a:lstStyle/>
+          <a:p>
+            <a:r>
+              <a:rPr b="1" sz="1300">
+                <a:latin typeface="Geist Mono"/>
+              </a:rPr>
+              <a:t>References</a:t>
+            </a:r>
+          </a:p>
+          <a:p>
+            <a:r>
+              <a:rPr b="0" sz="1100">
+                <a:latin typeface="Geist"/>
+              </a:rPr>
+              <a:t>Give credit and show the trail. Left column is the foundation: the two Doench Rule Sets [1][2], the
+Hsu/Lander/Zhang review [3], and the Zheng seed paper [4]. Right column is the modern neural-net line
+and the surveys [5][6][7][8]. Do not read every line -- point out that [1] gave us the data, [4] is
+the seed evidence our model reproduced, and [8] is the off-target-safety gap we cannot address.
+Transition: the one sentence to remember.</a:t>
+            </a:r>
+          </a:p>
+        </p:txBody>
+      </p:sp>
+      <p:sp>
+        <p:nvSpPr>
+          <p:cNvPr id="4" name="Slide Number Placeholder 3"/>
+          <p:cNvSpPr>
+            <a:spLocks noGrp="1"/>
+          </p:cNvSpPr>
+          <p:nvPr>
+            <p:ph type="sldNum" idx="5" sz="quarter"/>
+          </p:nvPr>
+        </p:nvSpPr>
+        <p:spPr/>
+      </p:sp>
+    </p:spTree>
+  </p:cSld>
+  <p:clrMapOvr>
+    <a:masterClrMapping/>
+  </p:clrMapOvr>
+</p:notes>
+</file>
+
+<file path=ppt/notesSlides/notesSlide16.xml><?xml version="1.0" encoding="utf-8"?>
+<p:notes xmlns:a="http://schemas.openxmlformats.org/drawingml/2006/main" xmlns:p="http://schemas.openxmlformats.org/presentationml/2006/main" xmlns:r="http://schemas.openxmlformats.org/officeDocument/2006/relationships">
+  <p:cSld>
+    <p:spTree>
+      <p:nvGrpSpPr>
+        <p:cNvPr id="1" name=""/>
+        <p:cNvGrpSpPr/>
+        <p:nvPr/>
+      </p:nvGrpSpPr>
+      <p:grpSpPr>
+        <a:xfrm>
+          <a:off x="0" y="0"/>
+          <a:ext cx="0" cy="0"/>
+          <a:chOff x="0" y="0"/>
+          <a:chExt cx="0" cy="0"/>
+        </a:xfrm>
+      </p:grpSpPr>
+      <p:sp>
+        <p:nvSpPr>
+          <p:cNvPr id="2" name="Slide Image Placeholder 1"/>
+          <p:cNvSpPr>
+            <a:spLocks noGrp="1"/>
+          </p:cNvSpPr>
+          <p:nvPr>
+            <p:ph type="sldImg" idx="2"/>
+          </p:nvPr>
+        </p:nvSpPr>
+        <p:spPr/>
+      </p:sp>
+      <p:sp>
+        <p:nvSpPr>
+          <p:cNvPr id="3" name="Notes Placeholder 2"/>
+          <p:cNvSpPr>
+            <a:spLocks noGrp="1"/>
+          </p:cNvSpPr>
+          <p:nvPr>
+            <p:ph type="body" idx="3" sz="quarter"/>
+          </p:nvPr>
+        </p:nvSpPr>
+        <p:spPr/>
+        <p:txBody>
+          <a:bodyPr/>
+          <a:lstStyle/>
+          <a:p>
+            <a:r>
+              <a:rPr b="1" sz="1300">
+                <a:latin typeface="Geist Mono"/>
+              </a:rPr>
               <a:t>The honest bottom line</a:t>
             </a:r>
           </a:p>
@@ -862,7 +1195,7 @@
               <a:rPr b="1" sz="1300">
                 <a:latin typeface="Geist Mono"/>
               </a:rPr>
-              <a:t>How real scientists pick a guide</a:t>
+              <a:t>What CRISPR actually is</a:t>
             </a:r>
           </a:p>
           <a:p>
@@ -870,11 +1203,11 @@
               <a:rPr b="0" sz="1100">
                 <a:latin typeface="Geist"/>
               </a:rPr>
-              <a:t>This is the professional context. Real guide selection is a scoring problem, not a guessing game.
-Name-drop the three ideas the way the field actually thinks about them: (1) the Doench Rule Set 2 /
-Azimuth model scores sequence directly [1][2]; (2) the seed region near the PAM dominates [3][4]; and
-(3) modern neural nets like DeepCRISPR push accuracy further with more data [5][6]. Students should
-leave knowing the seed idea. Transition: let's look at that seed effect as a picture.</a:t>
+              <a:t>Open concrete and physical. CRISPR-Cas9 is scissors plus a 20-letter address label. Point at the
+figure: the turquoise block is the guide/protospacer, the pink block just to its right is the PAM
+(always NGG), and Cas9 snips a few letters upstream. Every guide in our dataset is one of these
+20-letter strings. Do not mention machine learning yet -- just make sure they can read the picture.
+Transition: so how do real scientists decide which 20 letters to use?</a:t>
             </a:r>
           </a:p>
         </p:txBody>
@@ -947,7 +1280,7 @@
               <a:rPr b="1" sz="1300">
                 <a:latin typeface="Geist Mono"/>
               </a:rPr>
-              <a:t>The seed region matters most</a:t>
+              <a:t>How real scientists pick a guide</a:t>
             </a:r>
           </a:p>
           <a:p>
@@ -955,10 +1288,11 @@
               <a:rPr b="0" sz="1100">
                 <a:latin typeface="Geist"/>
               </a:rPr>
-              <a:t>Plant the single most important intuition: the 20 letters are not equal. The chart rises toward the
-PAM end -- that block is the seed. This is a redraw of the Zheng 2017 / Doench 2016 finding [4][1].
-Tell them to remember the shape, because the payoff slide later shows OUR model reproducing it from
-scratch. Transition: now to our actual project -- the task and the data.</a:t>
+              <a:t>This is the professional context. Real guide selection is a scoring problem, not a guessing game.
+Name-drop the three ideas the way the field actually thinks about them: (1) the Doench Rule Set 2 /
+Azimuth model scores sequence directly [1][2]; (2) the seed region near the PAM dominates [3][4]; and
+(3) modern neural nets like DeepCRISPR push accuracy further with more data [5][6]. Students should
+leave knowing the seed idea. Transition: let's look at that seed effect as a picture.</a:t>
             </a:r>
           </a:p>
         </p:txBody>
@@ -1031,7 +1365,7 @@
               <a:rPr b="1" sz="1300">
                 <a:latin typeface="Geist Mono"/>
               </a:rPr>
-              <a:t>The question we are asking</a:t>
+              <a:t>The seed region matters most</a:t>
             </a:r>
           </a:p>
           <a:p>
@@ -1039,11 +1373,10 @@
               <a:rPr b="0" sz="1100">
                 <a:latin typeface="Geist"/>
               </a:rPr>
-              <a:t>Set up the task in numbers. 5,310 real, lab-measured guides across 17 genes -- the same data behind
-the Rule Set 2 model [1]. The number to dwell on is the last one: only about 1 in 5 guides is a good
-cutter. That class imbalance is why, two slides from now, we refuse to trust plain accuracy. Say it
-out loud: an 'always low' model would be 80 percent accurate and completely useless. Transition: the
-first real decision -- how do we hand DNA letters to a model?</a:t>
+              <a:t>Plant the single most important intuition: the 20 letters are not equal. The chart rises toward the
+PAM end -- that block is the seed. This is a redraw of the Zheng 2017 / Doench 2016 finding [4][1].
+Tell them to remember the shape, because the payoff slide later shows OUR model reproducing it from
+scratch. Transition: now to our actual project -- the task and the data.</a:t>
             </a:r>
           </a:p>
         </p:txBody>
@@ -1116,7 +1449,7 @@
               <a:rPr b="1" sz="1300">
                 <a:latin typeface="Geist Mono"/>
               </a:rPr>
-              <a:t>Turning letters into numbers</a:t>
+              <a:t>Methods</a:t>
             </a:r>
           </a:p>
           <a:p>
@@ -1124,11 +1457,7 @@
               <a:rPr b="0" sz="1100">
                 <a:latin typeface="Geist"/>
               </a:rPr>
-              <a:t>The conceptual heart of the project. Featurizing = turning letters into numbers, and the choice
-encodes what you think matters. one-hot keeps position (80 numbers); k-mer keeps only counts (21
-numbers) and throws order away. The LISTEN/SILENT analogy is the whole lesson in two words: same
-letters, different meaning -- order matters. Because the seed is a POSITION effect, we predict one-hot
-wins. Make them commit to that prediction before the next slide. Transition: let's test it.</a:t>
+              <a:t>Now we turn that biology into a machine-learning task. Coming up: the exact dataset, the class imbalance, and the single decision that dominates everything -- how we turn DNA letters into numbers. Keep the seed idea handy, because it drives the prediction we are about to make.</a:t>
             </a:r>
           </a:p>
         </p:txBody>
@@ -1201,7 +1530,7 @@
               <a:rPr b="1" sz="1300">
                 <a:latin typeface="Geist Mono"/>
               </a:rPr>
-              <a:t>Keeping the letter order wins</a:t>
+              <a:t>The question we are asking</a:t>
             </a:r>
           </a:p>
           <a:p>
@@ -1209,11 +1538,11 @@
               <a:rPr b="0" sz="1100">
                 <a:latin typeface="Geist"/>
               </a:rPr>
-              <a:t>First result, and the transferable one. Same four models, two featurizations; one-hot wins across the
-board. The takeaway is bigger than CRISPR: data representation beat model choice. The prediction they
-made last slide came true, and for the right reason -- one-hot kept the position information where the
-signal lives. Best score is Random Forest on one-hot at AUC 0.77. Transition: wait, why AUC and not
-just accuracy?</a:t>
+              <a:t>Set up the task in numbers. 5,310 real, lab-measured guides across 17 genes -- the same data behind
+the Rule Set 2 model [1]. The number to dwell on is the last one: only about 1 in 5 guides is a good
+cutter. That class imbalance is why, two slides from now, we refuse to trust plain accuracy. Say it
+out loud: an 'always low' model would be 80 percent accurate and completely useless. Transition: the
+first real decision -- how do we hand DNA letters to a model?</a:t>
             </a:r>
           </a:p>
         </p:txBody>
@@ -1286,7 +1615,7 @@
               <a:rPr b="1" sz="1300">
                 <a:latin typeface="Geist Mono"/>
               </a:rPr>
-              <a:t>Why we grade with AUC, not accuracy</a:t>
+              <a:t>Turning letters into numbers</a:t>
             </a:r>
           </a:p>
           <a:p>
@@ -1294,11 +1623,11 @@
               <a:rPr b="0" sz="1100">
                 <a:latin typeface="Geist"/>
               </a:rPr>
-              <a:t>The judgment slide. On imbalanced data accuracy lies: an 'always low' model scores 80 percent and is
-worthless because it never flags a usable guide. AUC sidesteps the trick -- it measures whether the
-model RANKS good guides above bad ones, so 0.5 is a coin flip and 1.0 is perfect. Our 0.77 means real
-ranking skill. This same trap (accuracy on imbalanced data) shows up everywhere in medical AI, so it
-is worth over-teaching. Transition: now the most satisfying result.</a:t>
+              <a:t>The conceptual heart of the project. Featurizing = turning letters into numbers, and the choice
+encodes what you think matters. one-hot keeps position (80 numbers); k-mer keeps only counts (21
+numbers) and throws order away. The LISTEN/SILENT analogy is the whole lesson in two words: same
+letters, different meaning -- order matters. Because the seed is a POSITION effect, we predict one-hot
+wins. Make them commit to that prediction before the next slide. Transition: let's test it.</a:t>
             </a:r>
           </a:p>
         </p:txBody>
@@ -1371,7 +1700,7 @@
               <a:rPr b="1" sz="1300">
                 <a:latin typeface="Geist Mono"/>
               </a:rPr>
-              <a:t>The model rediscovered the seed</a:t>
+              <a:t>Results</a:t>
             </a:r>
           </a:p>
           <a:p>
@@ -1379,12 +1708,7 @@
               <a:rPr b="0" sz="1100">
                 <a:latin typeface="Geist"/>
               </a:rPr>
-              <a:t>The wow moment -- put it up and pause. We asked a plain logistic-regression model which of the 20
-positions it relied on, and the importance peaks at position 20, right at the PAM: the seed. Flip back
-to the background seed chart -- same shape. Nobody encoded that; the model recovered decades of CRISPR
-biology from sequences and cut-scores alone. Tie it to trust: an explainable model that matches known
-science is one clinicians and biologists will believe. Transition: can it predict the exact score,
-not just high vs low?</a:t>
+              <a:t>Time for what we found. Three beats here: keeping the letter order (one-hot) wins, why we grade with AUC instead of accuracy, and the payoff -- the model rediscovering the seed on its own. Then a harder task, predicting the exact cutting score.</a:t>
             </a:r>
           </a:p>
         </p:txBody>
@@ -1457,7 +1781,7 @@
               <a:rPr b="1" sz="1300">
                 <a:latin typeface="Geist Mono"/>
               </a:rPr>
-              <a:t>Predicting the exact score</a:t>
+              <a:t>Keeping the letter order wins</a:t>
             </a:r>
           </a:p>
           <a:p>
@@ -1465,11 +1789,11 @@
               <a:rPr b="0" sz="1100">
                 <a:latin typeface="Geist"/>
               </a:rPr>
-              <a:t>Second, harder task: predict the exact 0-to-1 score, not just a yes/no. Explain R-squared plainly --
-the fraction of the real variation the model captures, 0 is guessing the mean, 1 is perfect. We get
-0.36 (correlation 0.61): a real but loose trend, visible as a tilted cloud around the diagonal. The
-honest point: the professional predicted-vs-measured plots scatter just like ours [1][5][6]. Useful
-does not mean perfect. Transition: so let's be clear-eyed about what this toy can and cannot do.</a:t>
+              <a:t>First result, and the transferable one. Same four models, two featurizations; one-hot wins across the
+board. The takeaway is bigger than CRISPR: data representation beat model choice. The prediction they
+made last slide came true, and for the right reason -- one-hot kept the position information where the
+signal lives. Best score is Random Forest on one-hot at AUC 0.77. Transition: wait, why AUC and not
+just accuracy?</a:t>
             </a:r>
           </a:p>
         </p:txBody>
@@ -5643,8 +5967,8 @@
         </p:nvSpPr>
         <p:spPr>
           <a:xfrm>
-            <a:off x="731520" y="1956689"/>
-            <a:ext cx="4892040" cy="1371600"/>
+            <a:off x="731520" y="2144204"/>
+            <a:ext cx="4892040" cy="1554480"/>
           </a:xfrm>
           <a:prstGeom prst="rect">
             <a:avLst/>
@@ -5652,7 +5976,7 @@
           <a:noFill/>
         </p:spPr>
         <p:txBody>
-          <a:bodyPr wrap="square" anchor="t" lIns="0" rIns="0" tIns="0" bIns="0">
+          <a:bodyPr wrap="square" anchor="ctr" lIns="0" rIns="0" tIns="0" bIns="0">
             <a:spAutoFit/>
           </a:bodyPr>
           <a:lstStyle/>
@@ -5678,8 +6002,8 @@
         </p:nvSpPr>
         <p:spPr>
           <a:xfrm>
-            <a:off x="731520" y="3694049"/>
-            <a:ext cx="4892040" cy="2295271"/>
+            <a:off x="731520" y="3835844"/>
+            <a:ext cx="4892040" cy="1737360"/>
           </a:xfrm>
           <a:prstGeom prst="rect">
             <a:avLst/>
@@ -5757,8 +6081,8 @@
         </p:nvSpPr>
         <p:spPr>
           <a:xfrm>
-            <a:off x="6537960" y="1956689"/>
-            <a:ext cx="4892040" cy="1371600"/>
+            <a:off x="6537960" y="2144204"/>
+            <a:ext cx="4892040" cy="1554480"/>
           </a:xfrm>
           <a:prstGeom prst="rect">
             <a:avLst/>
@@ -5766,7 +6090,7 @@
           <a:noFill/>
         </p:spPr>
         <p:txBody>
-          <a:bodyPr wrap="square" anchor="t" lIns="0" rIns="0" tIns="0" bIns="0">
+          <a:bodyPr wrap="square" anchor="ctr" lIns="0" rIns="0" tIns="0" bIns="0">
             <a:spAutoFit/>
           </a:bodyPr>
           <a:lstStyle/>
@@ -5792,8 +6116,8 @@
         </p:nvSpPr>
         <p:spPr>
           <a:xfrm>
-            <a:off x="6537960" y="3694049"/>
-            <a:ext cx="4892040" cy="2295271"/>
+            <a:off x="6537960" y="3835844"/>
+            <a:ext cx="4892040" cy="1737360"/>
           </a:xfrm>
           <a:prstGeom prst="rect">
             <a:avLst/>
@@ -7367,14 +7691,14 @@
         </p:nvSpPr>
         <p:spPr>
           <a:xfrm>
-            <a:off x="457200" y="1545209"/>
-            <a:ext cx="3535680" cy="4626991"/>
+            <a:off x="502920" y="1600073"/>
+            <a:ext cx="3535680" cy="4581270"/>
           </a:xfrm>
           <a:prstGeom prst="rect">
             <a:avLst/>
           </a:prstGeom>
           <a:solidFill>
-            <a:srgbClr val="FAFAFC"/>
+            <a:srgbClr val="E4E1D9"/>
           </a:solidFill>
           <a:ln>
             <a:noFill/>
@@ -7412,7 +7736,51 @@
         <p:spPr>
           <a:xfrm>
             <a:off x="457200" y="1545209"/>
-            <a:ext cx="3535680" cy="54864"/>
+            <a:ext cx="3535680" cy="4581270"/>
+          </a:xfrm>
+          <a:prstGeom prst="rect">
+            <a:avLst/>
+          </a:prstGeom>
+          <a:solidFill>
+            <a:srgbClr val="FFFFFF"/>
+          </a:solidFill>
+          <a:ln>
+            <a:noFill/>
+          </a:ln>
+          <a:effectLst/>
+        </p:spPr>
+        <p:style>
+          <a:lnRef idx="1">
+            <a:schemeClr val="accent1"/>
+          </a:lnRef>
+          <a:fillRef idx="3">
+            <a:schemeClr val="accent1"/>
+          </a:fillRef>
+          <a:effectRef idx="2">
+            <a:schemeClr val="accent1"/>
+          </a:effectRef>
+          <a:fontRef idx="minor">
+            <a:schemeClr val="lt1"/>
+          </a:fontRef>
+        </p:style>
+        <p:txBody>
+          <a:bodyPr rtlCol="0" anchor="ctr"/>
+          <a:lstStyle/>
+          <a:p>
+            <a:pPr algn="ctr"/>
+          </a:p>
+        </p:txBody>
+      </p:sp>
+      <p:sp>
+        <p:nvSpPr>
+          <p:cNvPr id="10" name="Rectangle 9"/>
+          <p:cNvSpPr/>
+          <p:nvPr/>
+        </p:nvSpPr>
+        <p:spPr>
+          <a:xfrm>
+            <a:off x="457200" y="1545209"/>
+            <a:ext cx="3535680" cy="73152"/>
           </a:xfrm>
           <a:prstGeom prst="rect">
             <a:avLst/>
@@ -7449,14 +7817,14 @@
       </p:sp>
       <p:sp>
         <p:nvSpPr>
-          <p:cNvPr id="10" name="TextBox 9"/>
+          <p:cNvPr id="11" name="TextBox 10"/>
           <p:cNvSpPr txBox="1"/>
           <p:nvPr/>
         </p:nvSpPr>
         <p:spPr>
           <a:xfrm>
-            <a:off x="621792" y="1636649"/>
-            <a:ext cx="3206496" cy="384048"/>
+            <a:off x="713232" y="3058604"/>
+            <a:ext cx="3023616" cy="411480"/>
           </a:xfrm>
           <a:prstGeom prst="rect">
             <a:avLst/>
@@ -7471,7 +7839,7 @@
           <a:p>
             <a:pPr algn="l"/>
             <a:r>
-              <a:rPr sz="1400" b="1" i="0">
+              <a:rPr sz="1500" b="1" i="0">
                 <a:solidFill>
                   <a:srgbClr val="40E0D0"/>
                 </a:solidFill>
@@ -7484,14 +7852,14 @@
       </p:sp>
       <p:sp>
         <p:nvSpPr>
-          <p:cNvPr id="11" name="TextBox 10"/>
+          <p:cNvPr id="12" name="TextBox 11"/>
           <p:cNvSpPr txBox="1"/>
           <p:nvPr/>
         </p:nvSpPr>
         <p:spPr>
           <a:xfrm>
-            <a:off x="621792" y="2185289"/>
-            <a:ext cx="3206496" cy="3895471"/>
+            <a:off x="713232" y="3588956"/>
+            <a:ext cx="3023616" cy="2263203"/>
           </a:xfrm>
           <a:prstGeom prst="rect">
             <a:avLst/>
@@ -7506,7 +7874,7 @@
           <a:p>
             <a:pPr algn="l"/>
             <a:r>
-              <a:rPr sz="1200" b="0" i="0">
+              <a:rPr sz="1400" b="0" i="0">
                 <a:solidFill>
                   <a:srgbClr val="14141C"/>
                 </a:solidFill>
@@ -7519,20 +7887,20 @@
       </p:sp>
       <p:sp>
         <p:nvSpPr>
-          <p:cNvPr id="12" name="Rectangle 11"/>
+          <p:cNvPr id="13" name="Rectangle 12"/>
           <p:cNvSpPr/>
           <p:nvPr/>
         </p:nvSpPr>
         <p:spPr>
           <a:xfrm>
-            <a:off x="4312920" y="1545209"/>
-            <a:ext cx="3535680" cy="4626991"/>
+            <a:off x="4358640" y="1600073"/>
+            <a:ext cx="3535680" cy="4581270"/>
           </a:xfrm>
           <a:prstGeom prst="rect">
             <a:avLst/>
           </a:prstGeom>
           <a:solidFill>
-            <a:srgbClr val="FAFAFC"/>
+            <a:srgbClr val="E4E1D9"/>
           </a:solidFill>
           <a:ln>
             <a:noFill/>
@@ -7563,14 +7931,58 @@
       </p:sp>
       <p:sp>
         <p:nvSpPr>
-          <p:cNvPr id="13" name="Rectangle 12"/>
+          <p:cNvPr id="14" name="Rectangle 13"/>
           <p:cNvSpPr/>
           <p:nvPr/>
         </p:nvSpPr>
         <p:spPr>
           <a:xfrm>
             <a:off x="4312920" y="1545209"/>
-            <a:ext cx="3535680" cy="54864"/>
+            <a:ext cx="3535680" cy="4581270"/>
+          </a:xfrm>
+          <a:prstGeom prst="rect">
+            <a:avLst/>
+          </a:prstGeom>
+          <a:solidFill>
+            <a:srgbClr val="FFFFFF"/>
+          </a:solidFill>
+          <a:ln>
+            <a:noFill/>
+          </a:ln>
+          <a:effectLst/>
+        </p:spPr>
+        <p:style>
+          <a:lnRef idx="1">
+            <a:schemeClr val="accent1"/>
+          </a:lnRef>
+          <a:fillRef idx="3">
+            <a:schemeClr val="accent1"/>
+          </a:fillRef>
+          <a:effectRef idx="2">
+            <a:schemeClr val="accent1"/>
+          </a:effectRef>
+          <a:fontRef idx="minor">
+            <a:schemeClr val="lt1"/>
+          </a:fontRef>
+        </p:style>
+        <p:txBody>
+          <a:bodyPr rtlCol="0" anchor="ctr"/>
+          <a:lstStyle/>
+          <a:p>
+            <a:pPr algn="ctr"/>
+          </a:p>
+        </p:txBody>
+      </p:sp>
+      <p:sp>
+        <p:nvSpPr>
+          <p:cNvPr id="15" name="Rectangle 14"/>
+          <p:cNvSpPr/>
+          <p:nvPr/>
+        </p:nvSpPr>
+        <p:spPr>
+          <a:xfrm>
+            <a:off x="4312920" y="1545209"/>
+            <a:ext cx="3535680" cy="73152"/>
           </a:xfrm>
           <a:prstGeom prst="rect">
             <a:avLst/>
@@ -7607,14 +8019,14 @@
       </p:sp>
       <p:sp>
         <p:nvSpPr>
-          <p:cNvPr id="14" name="TextBox 13"/>
+          <p:cNvPr id="16" name="TextBox 15"/>
           <p:cNvSpPr txBox="1"/>
           <p:nvPr/>
         </p:nvSpPr>
         <p:spPr>
           <a:xfrm>
-            <a:off x="4477512" y="1636649"/>
-            <a:ext cx="3206496" cy="384048"/>
+            <a:off x="4568952" y="3058604"/>
+            <a:ext cx="3023616" cy="411480"/>
           </a:xfrm>
           <a:prstGeom prst="rect">
             <a:avLst/>
@@ -7629,7 +8041,7 @@
           <a:p>
             <a:pPr algn="l"/>
             <a:r>
-              <a:rPr sz="1400" b="1" i="0">
+              <a:rPr sz="1500" b="1" i="0">
                 <a:solidFill>
                   <a:srgbClr val="FF1493"/>
                 </a:solidFill>
@@ -7642,14 +8054,14 @@
       </p:sp>
       <p:sp>
         <p:nvSpPr>
-          <p:cNvPr id="15" name="TextBox 14"/>
+          <p:cNvPr id="17" name="TextBox 16"/>
           <p:cNvSpPr txBox="1"/>
           <p:nvPr/>
         </p:nvSpPr>
         <p:spPr>
           <a:xfrm>
-            <a:off x="4477512" y="2185289"/>
-            <a:ext cx="3206496" cy="3895471"/>
+            <a:off x="4568952" y="3588956"/>
+            <a:ext cx="3023616" cy="2263203"/>
           </a:xfrm>
           <a:prstGeom prst="rect">
             <a:avLst/>
@@ -7664,7 +8076,7 @@
           <a:p>
             <a:pPr algn="l"/>
             <a:r>
-              <a:rPr sz="1200" b="0" i="0">
+              <a:rPr sz="1400" b="0" i="0">
                 <a:solidFill>
                   <a:srgbClr val="14141C"/>
                 </a:solidFill>
@@ -7677,20 +8089,20 @@
       </p:sp>
       <p:sp>
         <p:nvSpPr>
-          <p:cNvPr id="16" name="Rectangle 15"/>
+          <p:cNvPr id="18" name="Rectangle 17"/>
           <p:cNvSpPr/>
           <p:nvPr/>
         </p:nvSpPr>
         <p:spPr>
           <a:xfrm>
-            <a:off x="8168640" y="1545209"/>
-            <a:ext cx="3535680" cy="4626991"/>
+            <a:off x="8214360" y="1600073"/>
+            <a:ext cx="3535680" cy="4581270"/>
           </a:xfrm>
           <a:prstGeom prst="rect">
             <a:avLst/>
           </a:prstGeom>
           <a:solidFill>
-            <a:srgbClr val="FAFAFC"/>
+            <a:srgbClr val="E4E1D9"/>
           </a:solidFill>
           <a:ln>
             <a:noFill/>
@@ -7721,14 +8133,58 @@
       </p:sp>
       <p:sp>
         <p:nvSpPr>
-          <p:cNvPr id="17" name="Rectangle 16"/>
+          <p:cNvPr id="19" name="Rectangle 18"/>
           <p:cNvSpPr/>
           <p:nvPr/>
         </p:nvSpPr>
         <p:spPr>
           <a:xfrm>
             <a:off x="8168640" y="1545209"/>
-            <a:ext cx="3535680" cy="54864"/>
+            <a:ext cx="3535680" cy="4581270"/>
+          </a:xfrm>
+          <a:prstGeom prst="rect">
+            <a:avLst/>
+          </a:prstGeom>
+          <a:solidFill>
+            <a:srgbClr val="FFFFFF"/>
+          </a:solidFill>
+          <a:ln>
+            <a:noFill/>
+          </a:ln>
+          <a:effectLst/>
+        </p:spPr>
+        <p:style>
+          <a:lnRef idx="1">
+            <a:schemeClr val="accent1"/>
+          </a:lnRef>
+          <a:fillRef idx="3">
+            <a:schemeClr val="accent1"/>
+          </a:fillRef>
+          <a:effectRef idx="2">
+            <a:schemeClr val="accent1"/>
+          </a:effectRef>
+          <a:fontRef idx="minor">
+            <a:schemeClr val="lt1"/>
+          </a:fontRef>
+        </p:style>
+        <p:txBody>
+          <a:bodyPr rtlCol="0" anchor="ctr"/>
+          <a:lstStyle/>
+          <a:p>
+            <a:pPr algn="ctr"/>
+          </a:p>
+        </p:txBody>
+      </p:sp>
+      <p:sp>
+        <p:nvSpPr>
+          <p:cNvPr id="20" name="Rectangle 19"/>
+          <p:cNvSpPr/>
+          <p:nvPr/>
+        </p:nvSpPr>
+        <p:spPr>
+          <a:xfrm>
+            <a:off x="8168640" y="1545209"/>
+            <a:ext cx="3535680" cy="73152"/>
           </a:xfrm>
           <a:prstGeom prst="rect">
             <a:avLst/>
@@ -7765,14 +8221,14 @@
       </p:sp>
       <p:sp>
         <p:nvSpPr>
-          <p:cNvPr id="18" name="TextBox 17"/>
+          <p:cNvPr id="21" name="TextBox 20"/>
           <p:cNvSpPr txBox="1"/>
           <p:nvPr/>
         </p:nvSpPr>
         <p:spPr>
           <a:xfrm>
-            <a:off x="8333232" y="1636649"/>
-            <a:ext cx="3206496" cy="384048"/>
+            <a:off x="8424672" y="3058604"/>
+            <a:ext cx="3023616" cy="411480"/>
           </a:xfrm>
           <a:prstGeom prst="rect">
             <a:avLst/>
@@ -7787,7 +8243,7 @@
           <a:p>
             <a:pPr algn="l"/>
             <a:r>
-              <a:rPr sz="1400" b="1" i="0">
+              <a:rPr sz="1500" b="1" i="0">
                 <a:solidFill>
                   <a:srgbClr val="8A2BE2"/>
                 </a:solidFill>
@@ -7800,14 +8256,14 @@
       </p:sp>
       <p:sp>
         <p:nvSpPr>
-          <p:cNvPr id="19" name="TextBox 18"/>
+          <p:cNvPr id="22" name="TextBox 21"/>
           <p:cNvSpPr txBox="1"/>
           <p:nvPr/>
         </p:nvSpPr>
         <p:spPr>
           <a:xfrm>
-            <a:off x="8333232" y="2185289"/>
-            <a:ext cx="3206496" cy="3895471"/>
+            <a:off x="8424672" y="3588956"/>
+            <a:ext cx="3023616" cy="2263203"/>
           </a:xfrm>
           <a:prstGeom prst="rect">
             <a:avLst/>
@@ -7822,7 +8278,7 @@
           <a:p>
             <a:pPr algn="l"/>
             <a:r>
-              <a:rPr sz="1200" b="0" i="0">
+              <a:rPr sz="1400" b="0" i="0">
                 <a:solidFill>
                   <a:srgbClr val="14141C"/>
                 </a:solidFill>
@@ -8462,7 +8918,7 @@
         </p:nvSpPr>
         <p:spPr>
           <a:xfrm>
-            <a:off x="457200" y="2615184"/>
+            <a:off x="457200" y="2510942"/>
             <a:ext cx="11247120" cy="1005840"/>
           </a:xfrm>
           <a:prstGeom prst="rect">
@@ -8478,7 +8934,7 @@
           <a:p>
             <a:pPr algn="ctr"/>
             <a:r>
-              <a:rPr sz="3000" b="1" i="0">
+              <a:rPr sz="3200" b="1" i="0">
                 <a:solidFill>
                   <a:srgbClr val="8A2BE2"/>
                 </a:solidFill>
@@ -8491,13 +8947,57 @@
       </p:sp>
       <p:sp>
         <p:nvSpPr>
-          <p:cNvPr id="8" name="TextBox 7"/>
+          <p:cNvPr id="8" name="Rectangle 7"/>
+          <p:cNvSpPr/>
+          <p:nvPr/>
+        </p:nvSpPr>
+        <p:spPr>
+          <a:xfrm>
+            <a:off x="4983480" y="3745382"/>
+            <a:ext cx="2194560" cy="45720"/>
+          </a:xfrm>
+          <a:prstGeom prst="rect">
+            <a:avLst/>
+          </a:prstGeom>
+          <a:solidFill>
+            <a:srgbClr val="8A2BE2"/>
+          </a:solidFill>
+          <a:ln>
+            <a:noFill/>
+          </a:ln>
+          <a:effectLst/>
+        </p:spPr>
+        <p:style>
+          <a:lnRef idx="1">
+            <a:schemeClr val="accent1"/>
+          </a:lnRef>
+          <a:fillRef idx="3">
+            <a:schemeClr val="accent1"/>
+          </a:fillRef>
+          <a:effectRef idx="2">
+            <a:schemeClr val="accent1"/>
+          </a:effectRef>
+          <a:fontRef idx="minor">
+            <a:schemeClr val="lt1"/>
+          </a:fontRef>
+        </p:style>
+        <p:txBody>
+          <a:bodyPr rtlCol="0" anchor="ctr"/>
+          <a:lstStyle/>
+          <a:p>
+            <a:pPr algn="ctr"/>
+          </a:p>
+        </p:txBody>
+      </p:sp>
+      <p:sp>
+        <p:nvSpPr>
+          <p:cNvPr id="9" name="TextBox 8"/>
           <p:cNvSpPr txBox="1"/>
           <p:nvPr/>
         </p:nvSpPr>
         <p:spPr>
           <a:xfrm>
-            <a:off x="1371600" y="4074566"/>
+            <a:off x="1371600" y="4248302"/>
             <a:ext cx="9418320" cy="914400"/>
           </a:xfrm>
           <a:prstGeom prst="rect">
@@ -8513,7 +9013,7 @@
           <a:p>
             <a:pPr algn="ctr"/>
             <a:r>
-              <a:rPr sz="1800" b="0" i="0">
+              <a:rPr sz="1900" b="0" i="0">
                 <a:solidFill>
                   <a:srgbClr val="14141C"/>
                 </a:solidFill>
@@ -9623,8 +10123,8 @@
         </p:blipFill>
         <p:spPr>
           <a:xfrm>
-            <a:off x="1547504" y="1792033"/>
-            <a:ext cx="9066511" cy="3968686"/>
+            <a:off x="2069743" y="1837753"/>
+            <a:ext cx="8022032" cy="3511486"/>
           </a:xfrm>
           <a:prstGeom prst="rect">
             <a:avLst/>
@@ -9639,8 +10139,8 @@
         </p:nvSpPr>
         <p:spPr>
           <a:xfrm>
-            <a:off x="457200" y="5833872"/>
-            <a:ext cx="11247120" cy="411480"/>
+            <a:off x="1371600" y="5468112"/>
+            <a:ext cx="9418320" cy="566928"/>
           </a:xfrm>
           <a:prstGeom prst="rect">
             <a:avLst/>
@@ -9929,14 +10429,14 @@
         </p:nvSpPr>
         <p:spPr>
           <a:xfrm>
-            <a:off x="457200" y="1792033"/>
-            <a:ext cx="3535680" cy="4380166"/>
+            <a:off x="502920" y="1846897"/>
+            <a:ext cx="3535680" cy="4334446"/>
           </a:xfrm>
           <a:prstGeom prst="rect">
             <a:avLst/>
           </a:prstGeom>
           <a:solidFill>
-            <a:srgbClr val="FAFAFC"/>
+            <a:srgbClr val="E4E1D9"/>
           </a:solidFill>
           <a:ln>
             <a:noFill/>
@@ -9974,7 +10474,51 @@
         <p:spPr>
           <a:xfrm>
             <a:off x="457200" y="1792033"/>
-            <a:ext cx="3535680" cy="54864"/>
+            <a:ext cx="3535680" cy="4334446"/>
+          </a:xfrm>
+          <a:prstGeom prst="rect">
+            <a:avLst/>
+          </a:prstGeom>
+          <a:solidFill>
+            <a:srgbClr val="FFFFFF"/>
+          </a:solidFill>
+          <a:ln>
+            <a:noFill/>
+          </a:ln>
+          <a:effectLst/>
+        </p:spPr>
+        <p:style>
+          <a:lnRef idx="1">
+            <a:schemeClr val="accent1"/>
+          </a:lnRef>
+          <a:fillRef idx="3">
+            <a:schemeClr val="accent1"/>
+          </a:fillRef>
+          <a:effectRef idx="2">
+            <a:schemeClr val="accent1"/>
+          </a:effectRef>
+          <a:fontRef idx="minor">
+            <a:schemeClr val="lt1"/>
+          </a:fontRef>
+        </p:style>
+        <p:txBody>
+          <a:bodyPr rtlCol="0" anchor="ctr"/>
+          <a:lstStyle/>
+          <a:p>
+            <a:pPr algn="ctr"/>
+          </a:p>
+        </p:txBody>
+      </p:sp>
+      <p:sp>
+        <p:nvSpPr>
+          <p:cNvPr id="10" name="Rectangle 9"/>
+          <p:cNvSpPr/>
+          <p:nvPr/>
+        </p:nvSpPr>
+        <p:spPr>
+          <a:xfrm>
+            <a:off x="457200" y="1792033"/>
+            <a:ext cx="3535680" cy="73152"/>
           </a:xfrm>
           <a:prstGeom prst="rect">
             <a:avLst/>
@@ -10011,14 +10555,14 @@
       </p:sp>
       <p:sp>
         <p:nvSpPr>
-          <p:cNvPr id="10" name="TextBox 9"/>
+          <p:cNvPr id="11" name="TextBox 10"/>
           <p:cNvSpPr txBox="1"/>
           <p:nvPr/>
         </p:nvSpPr>
         <p:spPr>
           <a:xfrm>
-            <a:off x="621792" y="1883473"/>
-            <a:ext cx="3206496" cy="384048"/>
+            <a:off x="713232" y="3090576"/>
+            <a:ext cx="3023616" cy="411480"/>
           </a:xfrm>
           <a:prstGeom prst="rect">
             <a:avLst/>
@@ -10033,7 +10577,7 @@
           <a:p>
             <a:pPr algn="l"/>
             <a:r>
-              <a:rPr sz="1400" b="1" i="0">
+              <a:rPr sz="1500" b="1" i="0">
                 <a:solidFill>
                   <a:srgbClr val="40E0D0"/>
                 </a:solidFill>
@@ -10046,14 +10590,14 @@
       </p:sp>
       <p:sp>
         <p:nvSpPr>
-          <p:cNvPr id="11" name="TextBox 10"/>
+          <p:cNvPr id="12" name="TextBox 11"/>
           <p:cNvSpPr txBox="1"/>
           <p:nvPr/>
         </p:nvSpPr>
         <p:spPr>
           <a:xfrm>
-            <a:off x="621792" y="2432113"/>
-            <a:ext cx="3206496" cy="3648646"/>
+            <a:off x="713232" y="3620928"/>
+            <a:ext cx="3023616" cy="2231231"/>
           </a:xfrm>
           <a:prstGeom prst="rect">
             <a:avLst/>
@@ -10068,7 +10612,7 @@
           <a:p>
             <a:pPr algn="l"/>
             <a:r>
-              <a:rPr sz="1200" b="0" i="0">
+              <a:rPr sz="1400" b="0" i="0">
                 <a:solidFill>
                   <a:srgbClr val="14141C"/>
                 </a:solidFill>
@@ -10081,20 +10625,20 @@
       </p:sp>
       <p:sp>
         <p:nvSpPr>
-          <p:cNvPr id="12" name="Rectangle 11"/>
+          <p:cNvPr id="13" name="Rectangle 12"/>
           <p:cNvSpPr/>
           <p:nvPr/>
         </p:nvSpPr>
         <p:spPr>
           <a:xfrm>
-            <a:off x="4312920" y="1792033"/>
-            <a:ext cx="3535680" cy="4380166"/>
+            <a:off x="4358640" y="1846897"/>
+            <a:ext cx="3535680" cy="4334446"/>
           </a:xfrm>
           <a:prstGeom prst="rect">
             <a:avLst/>
           </a:prstGeom>
           <a:solidFill>
-            <a:srgbClr val="FAFAFC"/>
+            <a:srgbClr val="E4E1D9"/>
           </a:solidFill>
           <a:ln>
             <a:noFill/>
@@ -10125,14 +10669,58 @@
       </p:sp>
       <p:sp>
         <p:nvSpPr>
-          <p:cNvPr id="13" name="Rectangle 12"/>
+          <p:cNvPr id="14" name="Rectangle 13"/>
           <p:cNvSpPr/>
           <p:nvPr/>
         </p:nvSpPr>
         <p:spPr>
           <a:xfrm>
             <a:off x="4312920" y="1792033"/>
-            <a:ext cx="3535680" cy="54864"/>
+            <a:ext cx="3535680" cy="4334446"/>
+          </a:xfrm>
+          <a:prstGeom prst="rect">
+            <a:avLst/>
+          </a:prstGeom>
+          <a:solidFill>
+            <a:srgbClr val="FFFFFF"/>
+          </a:solidFill>
+          <a:ln>
+            <a:noFill/>
+          </a:ln>
+          <a:effectLst/>
+        </p:spPr>
+        <p:style>
+          <a:lnRef idx="1">
+            <a:schemeClr val="accent1"/>
+          </a:lnRef>
+          <a:fillRef idx="3">
+            <a:schemeClr val="accent1"/>
+          </a:fillRef>
+          <a:effectRef idx="2">
+            <a:schemeClr val="accent1"/>
+          </a:effectRef>
+          <a:fontRef idx="minor">
+            <a:schemeClr val="lt1"/>
+          </a:fontRef>
+        </p:style>
+        <p:txBody>
+          <a:bodyPr rtlCol="0" anchor="ctr"/>
+          <a:lstStyle/>
+          <a:p>
+            <a:pPr algn="ctr"/>
+          </a:p>
+        </p:txBody>
+      </p:sp>
+      <p:sp>
+        <p:nvSpPr>
+          <p:cNvPr id="15" name="Rectangle 14"/>
+          <p:cNvSpPr/>
+          <p:nvPr/>
+        </p:nvSpPr>
+        <p:spPr>
+          <a:xfrm>
+            <a:off x="4312920" y="1792033"/>
+            <a:ext cx="3535680" cy="73152"/>
           </a:xfrm>
           <a:prstGeom prst="rect">
             <a:avLst/>
@@ -10169,14 +10757,14 @@
       </p:sp>
       <p:sp>
         <p:nvSpPr>
-          <p:cNvPr id="14" name="TextBox 13"/>
+          <p:cNvPr id="16" name="TextBox 15"/>
           <p:cNvSpPr txBox="1"/>
           <p:nvPr/>
         </p:nvSpPr>
         <p:spPr>
           <a:xfrm>
-            <a:off x="4477512" y="1883473"/>
-            <a:ext cx="3206496" cy="384048"/>
+            <a:off x="4568952" y="3090576"/>
+            <a:ext cx="3023616" cy="411480"/>
           </a:xfrm>
           <a:prstGeom prst="rect">
             <a:avLst/>
@@ -10191,7 +10779,7 @@
           <a:p>
             <a:pPr algn="l"/>
             <a:r>
-              <a:rPr sz="1400" b="1" i="0">
+              <a:rPr sz="1500" b="1" i="0">
                 <a:solidFill>
                   <a:srgbClr val="FF1493"/>
                 </a:solidFill>
@@ -10204,14 +10792,14 @@
       </p:sp>
       <p:sp>
         <p:nvSpPr>
-          <p:cNvPr id="15" name="TextBox 14"/>
+          <p:cNvPr id="17" name="TextBox 16"/>
           <p:cNvSpPr txBox="1"/>
           <p:nvPr/>
         </p:nvSpPr>
         <p:spPr>
           <a:xfrm>
-            <a:off x="4477512" y="2432113"/>
-            <a:ext cx="3206496" cy="3648646"/>
+            <a:off x="4568952" y="3620928"/>
+            <a:ext cx="3023616" cy="2231231"/>
           </a:xfrm>
           <a:prstGeom prst="rect">
             <a:avLst/>
@@ -10226,7 +10814,7 @@
           <a:p>
             <a:pPr algn="l"/>
             <a:r>
-              <a:rPr sz="1200" b="0" i="0">
+              <a:rPr sz="1400" b="0" i="0">
                 <a:solidFill>
                   <a:srgbClr val="14141C"/>
                 </a:solidFill>
@@ -10239,20 +10827,20 @@
       </p:sp>
       <p:sp>
         <p:nvSpPr>
-          <p:cNvPr id="16" name="Rectangle 15"/>
+          <p:cNvPr id="18" name="Rectangle 17"/>
           <p:cNvSpPr/>
           <p:nvPr/>
         </p:nvSpPr>
         <p:spPr>
           <a:xfrm>
-            <a:off x="8168640" y="1792033"/>
-            <a:ext cx="3535680" cy="4380166"/>
+            <a:off x="8214360" y="1846897"/>
+            <a:ext cx="3535680" cy="4334446"/>
           </a:xfrm>
           <a:prstGeom prst="rect">
             <a:avLst/>
           </a:prstGeom>
           <a:solidFill>
-            <a:srgbClr val="FAFAFC"/>
+            <a:srgbClr val="E4E1D9"/>
           </a:solidFill>
           <a:ln>
             <a:noFill/>
@@ -10283,14 +10871,58 @@
       </p:sp>
       <p:sp>
         <p:nvSpPr>
-          <p:cNvPr id="17" name="Rectangle 16"/>
+          <p:cNvPr id="19" name="Rectangle 18"/>
           <p:cNvSpPr/>
           <p:nvPr/>
         </p:nvSpPr>
         <p:spPr>
           <a:xfrm>
             <a:off x="8168640" y="1792033"/>
-            <a:ext cx="3535680" cy="54864"/>
+            <a:ext cx="3535680" cy="4334446"/>
+          </a:xfrm>
+          <a:prstGeom prst="rect">
+            <a:avLst/>
+          </a:prstGeom>
+          <a:solidFill>
+            <a:srgbClr val="FFFFFF"/>
+          </a:solidFill>
+          <a:ln>
+            <a:noFill/>
+          </a:ln>
+          <a:effectLst/>
+        </p:spPr>
+        <p:style>
+          <a:lnRef idx="1">
+            <a:schemeClr val="accent1"/>
+          </a:lnRef>
+          <a:fillRef idx="3">
+            <a:schemeClr val="accent1"/>
+          </a:fillRef>
+          <a:effectRef idx="2">
+            <a:schemeClr val="accent1"/>
+          </a:effectRef>
+          <a:fontRef idx="minor">
+            <a:schemeClr val="lt1"/>
+          </a:fontRef>
+        </p:style>
+        <p:txBody>
+          <a:bodyPr rtlCol="0" anchor="ctr"/>
+          <a:lstStyle/>
+          <a:p>
+            <a:pPr algn="ctr"/>
+          </a:p>
+        </p:txBody>
+      </p:sp>
+      <p:sp>
+        <p:nvSpPr>
+          <p:cNvPr id="20" name="Rectangle 19"/>
+          <p:cNvSpPr/>
+          <p:nvPr/>
+        </p:nvSpPr>
+        <p:spPr>
+          <a:xfrm>
+            <a:off x="8168640" y="1792033"/>
+            <a:ext cx="3535680" cy="73152"/>
           </a:xfrm>
           <a:prstGeom prst="rect">
             <a:avLst/>
@@ -10327,14 +10959,14 @@
       </p:sp>
       <p:sp>
         <p:nvSpPr>
-          <p:cNvPr id="18" name="TextBox 17"/>
+          <p:cNvPr id="21" name="TextBox 20"/>
           <p:cNvSpPr txBox="1"/>
           <p:nvPr/>
         </p:nvSpPr>
         <p:spPr>
           <a:xfrm>
-            <a:off x="8333232" y="1883473"/>
-            <a:ext cx="3206496" cy="384048"/>
+            <a:off x="8424672" y="3090576"/>
+            <a:ext cx="3023616" cy="411480"/>
           </a:xfrm>
           <a:prstGeom prst="rect">
             <a:avLst/>
@@ -10349,7 +10981,7 @@
           <a:p>
             <a:pPr algn="l"/>
             <a:r>
-              <a:rPr sz="1400" b="1" i="0">
+              <a:rPr sz="1500" b="1" i="0">
                 <a:solidFill>
                   <a:srgbClr val="8A2BE2"/>
                 </a:solidFill>
@@ -10362,14 +10994,14 @@
       </p:sp>
       <p:sp>
         <p:nvSpPr>
-          <p:cNvPr id="19" name="TextBox 18"/>
+          <p:cNvPr id="22" name="TextBox 21"/>
           <p:cNvSpPr txBox="1"/>
           <p:nvPr/>
         </p:nvSpPr>
         <p:spPr>
           <a:xfrm>
-            <a:off x="8333232" y="2432113"/>
-            <a:ext cx="3206496" cy="3648646"/>
+            <a:off x="8424672" y="3620928"/>
+            <a:ext cx="3023616" cy="2231231"/>
           </a:xfrm>
           <a:prstGeom prst="rect">
             <a:avLst/>
@@ -10384,7 +11016,7 @@
           <a:p>
             <a:pPr algn="l"/>
             <a:r>
-              <a:rPr sz="1200" b="0" i="0">
+              <a:rPr sz="1400" b="0" i="0">
                 <a:solidFill>
                   <a:srgbClr val="14141C"/>
                 </a:solidFill>
@@ -11533,8 +12165,8 @@
         </p:nvSpPr>
         <p:spPr>
           <a:xfrm>
-            <a:off x="713232" y="2294953"/>
-            <a:ext cx="3023616" cy="1371600"/>
+            <a:off x="713232" y="2404776"/>
+            <a:ext cx="3023616" cy="1417320"/>
           </a:xfrm>
           <a:prstGeom prst="rect">
             <a:avLst/>
@@ -11542,7 +12174,7 @@
           <a:noFill/>
         </p:spPr>
         <p:txBody>
-          <a:bodyPr wrap="square" anchor="t" lIns="0" rIns="0" tIns="0" bIns="0">
+          <a:bodyPr wrap="square" anchor="ctr" lIns="0" rIns="0" tIns="0" bIns="0">
             <a:spAutoFit/>
           </a:bodyPr>
           <a:lstStyle/>
@@ -11568,8 +12200,8 @@
         </p:nvSpPr>
         <p:spPr>
           <a:xfrm>
-            <a:off x="713232" y="3940873"/>
-            <a:ext cx="3023616" cy="2048446"/>
+            <a:off x="713232" y="3959256"/>
+            <a:ext cx="3023616" cy="1600200"/>
           </a:xfrm>
           <a:prstGeom prst="rect">
             <a:avLst/>
@@ -11647,8 +12279,8 @@
         </p:nvSpPr>
         <p:spPr>
           <a:xfrm>
-            <a:off x="4568952" y="2294953"/>
-            <a:ext cx="3023616" cy="1371600"/>
+            <a:off x="4568952" y="2404776"/>
+            <a:ext cx="3023616" cy="1417320"/>
           </a:xfrm>
           <a:prstGeom prst="rect">
             <a:avLst/>
@@ -11656,7 +12288,7 @@
           <a:noFill/>
         </p:spPr>
         <p:txBody>
-          <a:bodyPr wrap="square" anchor="t" lIns="0" rIns="0" tIns="0" bIns="0">
+          <a:bodyPr wrap="square" anchor="ctr" lIns="0" rIns="0" tIns="0" bIns="0">
             <a:spAutoFit/>
           </a:bodyPr>
           <a:lstStyle/>
@@ -11682,8 +12314,8 @@
         </p:nvSpPr>
         <p:spPr>
           <a:xfrm>
-            <a:off x="4568952" y="3940873"/>
-            <a:ext cx="3023616" cy="2048446"/>
+            <a:off x="4568952" y="3959256"/>
+            <a:ext cx="3023616" cy="1600200"/>
           </a:xfrm>
           <a:prstGeom prst="rect">
             <a:avLst/>
@@ -11761,8 +12393,8 @@
         </p:nvSpPr>
         <p:spPr>
           <a:xfrm>
-            <a:off x="8424672" y="2294953"/>
-            <a:ext cx="3023616" cy="1371600"/>
+            <a:off x="8424672" y="2404776"/>
+            <a:ext cx="3023616" cy="1417320"/>
           </a:xfrm>
           <a:prstGeom prst="rect">
             <a:avLst/>
@@ -11770,7 +12402,7 @@
           <a:noFill/>
         </p:spPr>
         <p:txBody>
-          <a:bodyPr wrap="square" anchor="t" lIns="0" rIns="0" tIns="0" bIns="0">
+          <a:bodyPr wrap="square" anchor="ctr" lIns="0" rIns="0" tIns="0" bIns="0">
             <a:spAutoFit/>
           </a:bodyPr>
           <a:lstStyle/>
@@ -11796,8 +12428,8 @@
         </p:nvSpPr>
         <p:spPr>
           <a:xfrm>
-            <a:off x="8424672" y="3940873"/>
-            <a:ext cx="3023616" cy="2048446"/>
+            <a:off x="8424672" y="3959256"/>
+            <a:ext cx="3023616" cy="1600200"/>
           </a:xfrm>
           <a:prstGeom prst="rect">
             <a:avLst/>
@@ -12086,14 +12718,14 @@
         </p:nvSpPr>
         <p:spPr>
           <a:xfrm>
-            <a:off x="457200" y="1792033"/>
-            <a:ext cx="5463540" cy="2825686"/>
+            <a:off x="502920" y="1846897"/>
+            <a:ext cx="5463540" cy="2551366"/>
           </a:xfrm>
           <a:prstGeom prst="rect">
             <a:avLst/>
           </a:prstGeom>
           <a:solidFill>
-            <a:srgbClr val="FAFAFC"/>
+            <a:srgbClr val="E4E1D9"/>
           </a:solidFill>
           <a:ln>
             <a:noFill/>
@@ -12131,7 +12763,51 @@
         <p:spPr>
           <a:xfrm>
             <a:off x="457200" y="1792033"/>
-            <a:ext cx="5463540" cy="54864"/>
+            <a:ext cx="5463540" cy="2551366"/>
+          </a:xfrm>
+          <a:prstGeom prst="rect">
+            <a:avLst/>
+          </a:prstGeom>
+          <a:solidFill>
+            <a:srgbClr val="FFFFFF"/>
+          </a:solidFill>
+          <a:ln>
+            <a:noFill/>
+          </a:ln>
+          <a:effectLst/>
+        </p:spPr>
+        <p:style>
+          <a:lnRef idx="1">
+            <a:schemeClr val="accent1"/>
+          </a:lnRef>
+          <a:fillRef idx="3">
+            <a:schemeClr val="accent1"/>
+          </a:fillRef>
+          <a:effectRef idx="2">
+            <a:schemeClr val="accent1"/>
+          </a:effectRef>
+          <a:fontRef idx="minor">
+            <a:schemeClr val="lt1"/>
+          </a:fontRef>
+        </p:style>
+        <p:txBody>
+          <a:bodyPr rtlCol="0" anchor="ctr"/>
+          <a:lstStyle/>
+          <a:p>
+            <a:pPr algn="ctr"/>
+          </a:p>
+        </p:txBody>
+      </p:sp>
+      <p:sp>
+        <p:nvSpPr>
+          <p:cNvPr id="10" name="Rectangle 9"/>
+          <p:cNvSpPr/>
+          <p:nvPr/>
+        </p:nvSpPr>
+        <p:spPr>
+          <a:xfrm>
+            <a:off x="457200" y="1792033"/>
+            <a:ext cx="5463540" cy="73152"/>
           </a:xfrm>
           <a:prstGeom prst="rect">
             <a:avLst/>
@@ -12168,14 +12844,14 @@
       </p:sp>
       <p:sp>
         <p:nvSpPr>
-          <p:cNvPr id="10" name="TextBox 9"/>
+          <p:cNvPr id="11" name="TextBox 10"/>
           <p:cNvSpPr txBox="1"/>
           <p:nvPr/>
         </p:nvSpPr>
         <p:spPr>
           <a:xfrm>
-            <a:off x="621792" y="1883473"/>
-            <a:ext cx="5134356" cy="384048"/>
+            <a:off x="713232" y="2450496"/>
+            <a:ext cx="4951476" cy="411480"/>
           </a:xfrm>
           <a:prstGeom prst="rect">
             <a:avLst/>
@@ -12190,7 +12866,7 @@
           <a:p>
             <a:pPr algn="l"/>
             <a:r>
-              <a:rPr sz="1400" b="1" i="0">
+              <a:rPr sz="1600" b="1" i="0">
                 <a:solidFill>
                   <a:srgbClr val="40E0D0"/>
                 </a:solidFill>
@@ -12203,14 +12879,14 @@
       </p:sp>
       <p:sp>
         <p:nvSpPr>
-          <p:cNvPr id="11" name="TextBox 10"/>
+          <p:cNvPr id="12" name="TextBox 11"/>
           <p:cNvSpPr txBox="1"/>
           <p:nvPr/>
         </p:nvSpPr>
         <p:spPr>
           <a:xfrm>
-            <a:off x="621792" y="2432113"/>
-            <a:ext cx="5134356" cy="2094166"/>
+            <a:off x="713232" y="2999136"/>
+            <a:ext cx="4951476" cy="1115663"/>
           </a:xfrm>
           <a:prstGeom prst="rect">
             <a:avLst/>
@@ -12225,7 +12901,7 @@
           <a:p>
             <a:pPr algn="l"/>
             <a:r>
-              <a:rPr sz="1200" b="0" i="0">
+              <a:rPr sz="1500" b="0" i="0">
                 <a:solidFill>
                   <a:srgbClr val="14141C"/>
                 </a:solidFill>
@@ -12238,20 +12914,20 @@
       </p:sp>
       <p:sp>
         <p:nvSpPr>
-          <p:cNvPr id="12" name="Rectangle 11"/>
+          <p:cNvPr id="13" name="Rectangle 12"/>
           <p:cNvSpPr/>
           <p:nvPr/>
         </p:nvSpPr>
         <p:spPr>
           <a:xfrm>
-            <a:off x="6240780" y="1792033"/>
-            <a:ext cx="5463540" cy="2825686"/>
+            <a:off x="6286500" y="1846897"/>
+            <a:ext cx="5463540" cy="2551366"/>
           </a:xfrm>
           <a:prstGeom prst="rect">
             <a:avLst/>
           </a:prstGeom>
           <a:solidFill>
-            <a:srgbClr val="FAFAFC"/>
+            <a:srgbClr val="E4E1D9"/>
           </a:solidFill>
           <a:ln>
             <a:noFill/>
@@ -12282,14 +12958,58 @@
       </p:sp>
       <p:sp>
         <p:nvSpPr>
-          <p:cNvPr id="13" name="Rectangle 12"/>
+          <p:cNvPr id="14" name="Rectangle 13"/>
           <p:cNvSpPr/>
           <p:nvPr/>
         </p:nvSpPr>
         <p:spPr>
           <a:xfrm>
             <a:off x="6240780" y="1792033"/>
-            <a:ext cx="5463540" cy="54864"/>
+            <a:ext cx="5463540" cy="2551366"/>
+          </a:xfrm>
+          <a:prstGeom prst="rect">
+            <a:avLst/>
+          </a:prstGeom>
+          <a:solidFill>
+            <a:srgbClr val="FFFFFF"/>
+          </a:solidFill>
+          <a:ln>
+            <a:noFill/>
+          </a:ln>
+          <a:effectLst/>
+        </p:spPr>
+        <p:style>
+          <a:lnRef idx="1">
+            <a:schemeClr val="accent1"/>
+          </a:lnRef>
+          <a:fillRef idx="3">
+            <a:schemeClr val="accent1"/>
+          </a:fillRef>
+          <a:effectRef idx="2">
+            <a:schemeClr val="accent1"/>
+          </a:effectRef>
+          <a:fontRef idx="minor">
+            <a:schemeClr val="lt1"/>
+          </a:fontRef>
+        </p:style>
+        <p:txBody>
+          <a:bodyPr rtlCol="0" anchor="ctr"/>
+          <a:lstStyle/>
+          <a:p>
+            <a:pPr algn="ctr"/>
+          </a:p>
+        </p:txBody>
+      </p:sp>
+      <p:sp>
+        <p:nvSpPr>
+          <p:cNvPr id="15" name="Rectangle 14"/>
+          <p:cNvSpPr/>
+          <p:nvPr/>
+        </p:nvSpPr>
+        <p:spPr>
+          <a:xfrm>
+            <a:off x="6240780" y="1792033"/>
+            <a:ext cx="5463540" cy="73152"/>
           </a:xfrm>
           <a:prstGeom prst="rect">
             <a:avLst/>
@@ -12326,14 +13046,14 @@
       </p:sp>
       <p:sp>
         <p:nvSpPr>
-          <p:cNvPr id="14" name="TextBox 13"/>
+          <p:cNvPr id="16" name="TextBox 15"/>
           <p:cNvSpPr txBox="1"/>
           <p:nvPr/>
         </p:nvSpPr>
         <p:spPr>
           <a:xfrm>
-            <a:off x="6405372" y="1883473"/>
-            <a:ext cx="5134356" cy="384048"/>
+            <a:off x="6496812" y="2450496"/>
+            <a:ext cx="4951476" cy="411480"/>
           </a:xfrm>
           <a:prstGeom prst="rect">
             <a:avLst/>
@@ -12348,7 +13068,7 @@
           <a:p>
             <a:pPr algn="l"/>
             <a:r>
-              <a:rPr sz="1400" b="1" i="0">
+              <a:rPr sz="1600" b="1" i="0">
                 <a:solidFill>
                   <a:srgbClr val="F0C840"/>
                 </a:solidFill>
@@ -12361,14 +13081,14 @@
       </p:sp>
       <p:sp>
         <p:nvSpPr>
-          <p:cNvPr id="15" name="TextBox 14"/>
+          <p:cNvPr id="17" name="TextBox 16"/>
           <p:cNvSpPr txBox="1"/>
           <p:nvPr/>
         </p:nvSpPr>
         <p:spPr>
           <a:xfrm>
-            <a:off x="6405372" y="2432113"/>
-            <a:ext cx="5134356" cy="2094166"/>
+            <a:off x="6496812" y="2999136"/>
+            <a:ext cx="4951476" cy="1115663"/>
           </a:xfrm>
           <a:prstGeom prst="rect">
             <a:avLst/>
@@ -12383,7 +13103,7 @@
           <a:p>
             <a:pPr algn="l"/>
             <a:r>
-              <a:rPr sz="1200" b="0" i="0">
+              <a:rPr sz="1500" b="0" i="0">
                 <a:solidFill>
                   <a:srgbClr val="14141C"/>
                 </a:solidFill>
@@ -12396,14 +13116,14 @@
       </p:sp>
       <p:sp>
         <p:nvSpPr>
-          <p:cNvPr id="16" name="Rectangle 15"/>
+          <p:cNvPr id="18" name="Rectangle 17"/>
           <p:cNvSpPr/>
           <p:nvPr/>
         </p:nvSpPr>
         <p:spPr>
           <a:xfrm>
-            <a:off x="457200" y="4937759"/>
-            <a:ext cx="11247120" cy="1325880"/>
+            <a:off x="457200" y="4709160"/>
+            <a:ext cx="11247120" cy="1417320"/>
           </a:xfrm>
           <a:prstGeom prst="rect">
             <a:avLst/>
@@ -12440,14 +13160,14 @@
       </p:sp>
       <p:sp>
         <p:nvSpPr>
-          <p:cNvPr id="17" name="TextBox 16"/>
+          <p:cNvPr id="19" name="TextBox 18"/>
           <p:cNvSpPr txBox="1"/>
           <p:nvPr/>
         </p:nvSpPr>
         <p:spPr>
           <a:xfrm>
-            <a:off x="731520" y="5084063"/>
-            <a:ext cx="10698480" cy="457200"/>
+            <a:off x="749808" y="4928616"/>
+            <a:ext cx="10661904" cy="457200"/>
           </a:xfrm>
           <a:prstGeom prst="rect">
             <a:avLst/>
@@ -12475,14 +13195,14 @@
       </p:sp>
       <p:sp>
         <p:nvSpPr>
-          <p:cNvPr id="18" name="TextBox 17"/>
+          <p:cNvPr id="20" name="TextBox 19"/>
           <p:cNvSpPr txBox="1"/>
           <p:nvPr/>
         </p:nvSpPr>
         <p:spPr>
           <a:xfrm>
-            <a:off x="731520" y="5650991"/>
-            <a:ext cx="10698480" cy="548640"/>
+            <a:off x="749808" y="5513832"/>
+            <a:ext cx="10661904" cy="502920"/>
           </a:xfrm>
           <a:prstGeom prst="rect">
             <a:avLst/>

</xml_diff>

<commit_message>
G1: add population-genetics equity slide (ancestry bias in reference genomes; Popejoy 2016, Sirugo 2019) + bespoke figure + notebook cell
</commit_message>
<xml_diff>
--- a/solutions/g1_crispr/slides/g1_crispr.pptx
+++ b/solutions/g1_crispr/slides/g1_crispr.pptx
@@ -28,6 +28,7 @@
     <p:sldId id="276" r:id="rId28"/>
     <p:sldId id="277" r:id="rId29"/>
     <p:sldId id="278" r:id="rId30"/>
+    <p:sldId id="279" r:id="rId31"/>
   </p:sldIdLst>
   <p:sldSz cx="12191695" cy="6858000" type="screen4x3"/>
   <p:notesSz cx="6858000" cy="9144000"/>
@@ -1499,7 +1500,7 @@
               <a:rPr b="1" sz="1300">
                 <a:latin typeface="Geist Mono"/>
               </a:rPr>
-              <a:t>References</a:t>
+              <a:t>Where equity lives in genome editing</a:t>
             </a:r>
           </a:p>
           <a:p>
@@ -1507,7 +1508,7 @@
               <a:rPr b="0" sz="1100">
                 <a:latin typeface="Geist"/>
               </a:rPr>
-              <a:t>Give credit and show the trail. Left column, the foundations and the data: Doench's Rule Set 2 and the dataset [1], the earlier position/PAM rules [2], the Hsu review that explains the seed [3], and the direct seed evidence [4] -- [1], [3] and [4] are the papers we redrew in the intro. Right column, the methods and reviews: the deep-learning tools that push further [5][6], a survey of predictors [7], and a recent explainable-AI + off-target piece [8]. Transition: the one sentence to remember.</a:t>
+              <a:t>Honest depth after 'what it can and cannot do'. Our data (guide sequences) has no patients, so per-guide fairness genuinely does not apply -- but genome editing DOES have a real equity problem one level up. Reference genomes and the variant databases we design against skew heavily European (GWAS participants are ~78% European, Sirugo et al. 2019). A variant that is common in an under-represented ancestry but absent from the reference can sit right under the guide or the PAM -- creating a mismatch, an altered PAM, or a brand-new off-target site -- so a guide that looks great on the reference may cut less well, or less safely, for those patients. The good news: the data to check this already exists -- gnomAD and 1000 Genomes carry ancestry-labeled variant frequencies, so guides overlapping ancestry-variable sites can be flagged before the lab. Two landmark commentaries frame the problem: Popejoy &amp; Fullerton 2016 and Sirugo, Williams &amp; Tishkoff 2019. Transition: the full reference list.</a:t>
             </a:r>
           </a:p>
         </p:txBody>
@@ -1533,6 +1534,87 @@
 </file>
 
 <file path=ppt/notesSlides/notesSlide21.xml><?xml version="1.0" encoding="utf-8"?>
+<p:notes xmlns:a="http://schemas.openxmlformats.org/drawingml/2006/main" xmlns:p="http://schemas.openxmlformats.org/presentationml/2006/main" xmlns:r="http://schemas.openxmlformats.org/officeDocument/2006/relationships">
+  <p:cSld>
+    <p:spTree>
+      <p:nvGrpSpPr>
+        <p:cNvPr id="1" name=""/>
+        <p:cNvGrpSpPr/>
+        <p:nvPr/>
+      </p:nvGrpSpPr>
+      <p:grpSpPr>
+        <a:xfrm>
+          <a:off x="0" y="0"/>
+          <a:ext cx="0" cy="0"/>
+          <a:chOff x="0" y="0"/>
+          <a:chExt cx="0" cy="0"/>
+        </a:xfrm>
+      </p:grpSpPr>
+      <p:sp>
+        <p:nvSpPr>
+          <p:cNvPr id="2" name="Slide Image Placeholder 1"/>
+          <p:cNvSpPr>
+            <a:spLocks noGrp="1"/>
+          </p:cNvSpPr>
+          <p:nvPr>
+            <p:ph type="sldImg" idx="2"/>
+          </p:nvPr>
+        </p:nvSpPr>
+        <p:spPr/>
+      </p:sp>
+      <p:sp>
+        <p:nvSpPr>
+          <p:cNvPr id="3" name="Notes Placeholder 2"/>
+          <p:cNvSpPr>
+            <a:spLocks noGrp="1"/>
+          </p:cNvSpPr>
+          <p:nvPr>
+            <p:ph type="body" idx="3" sz="quarter"/>
+          </p:nvPr>
+        </p:nvSpPr>
+        <p:spPr/>
+        <p:txBody>
+          <a:bodyPr/>
+          <a:lstStyle/>
+          <a:p>
+            <a:r>
+              <a:rPr b="1" sz="1300">
+                <a:latin typeface="Geist Mono"/>
+              </a:rPr>
+              <a:t>References</a:t>
+            </a:r>
+          </a:p>
+          <a:p>
+            <a:r>
+              <a:rPr b="0" sz="1100">
+                <a:latin typeface="Geist"/>
+              </a:rPr>
+              <a:t>Give credit and show the trail. Left column, the foundations and the data: Doench's Rule Set 2 and the dataset [1], the earlier position/PAM rules [2], the Hsu review that explains the seed [3], and the direct seed evidence [4] -- [1], [3] and [4] are the papers we redrew in the intro. Right column, the methods and reviews: the deep-learning tools that push further [5][6], a survey of predictors [7], and a recent explainable-AI + off-target piece [8]. Transition: the one sentence to remember.</a:t>
+            </a:r>
+          </a:p>
+        </p:txBody>
+      </p:sp>
+      <p:sp>
+        <p:nvSpPr>
+          <p:cNvPr id="4" name="Slide Number Placeholder 3"/>
+          <p:cNvSpPr>
+            <a:spLocks noGrp="1"/>
+          </p:cNvSpPr>
+          <p:nvPr>
+            <p:ph type="sldNum" idx="5" sz="quarter"/>
+          </p:nvPr>
+        </p:nvSpPr>
+        <p:spPr/>
+      </p:sp>
+    </p:spTree>
+  </p:cSld>
+  <p:clrMapOvr>
+    <a:masterClrMapping/>
+  </p:clrMapOvr>
+</p:notes>
+</file>
+
+<file path=ppt/notesSlides/notesSlide22.xml><?xml version="1.0" encoding="utf-8"?>
 <p:notes xmlns:a="http://schemas.openxmlformats.org/drawingml/2006/main" xmlns:p="http://schemas.openxmlformats.org/presentationml/2006/main" xmlns:r="http://schemas.openxmlformats.org/officeDocument/2006/relationships">
   <p:cSld>
     <p:spTree>
@@ -14634,7 +14716,7 @@
                 </a:solidFill>
                 <a:latin typeface="Geist Mono"/>
               </a:rPr>
-              <a:t>References</a:t>
+              <a:t>Where equity lives in genome editing</a:t>
             </a:r>
           </a:p>
         </p:txBody>
@@ -14718,16 +14800,40 @@
           </a:p>
         </p:txBody>
       </p:sp>
-      <p:sp>
-        <p:nvSpPr>
-          <p:cNvPr id="7" name="TextBox 6"/>
+      <p:pic>
+        <p:nvPicPr>
+          <p:cNvPr id="7" name="Picture 6" descr="intro_equity_ancestry.png"/>
+          <p:cNvPicPr>
+            <a:picLocks noChangeAspect="1"/>
+          </p:cNvPicPr>
+          <p:nvPr/>
+        </p:nvPicPr>
+        <p:blipFill>
+          <a:blip r:embed="rId2"/>
+          <a:stretch>
+            <a:fillRect/>
+          </a:stretch>
+        </p:blipFill>
+        <p:spPr>
+          <a:xfrm>
+            <a:off x="457200" y="1353345"/>
+            <a:ext cx="4846320" cy="3739829"/>
+          </a:xfrm>
+          <a:prstGeom prst="rect">
+            <a:avLst/>
+          </a:prstGeom>
+        </p:spPr>
+      </p:pic>
+      <p:sp>
+        <p:nvSpPr>
+          <p:cNvPr id="8" name="TextBox 7"/>
           <p:cNvSpPr txBox="1"/>
           <p:nvPr/>
         </p:nvSpPr>
         <p:spPr>
           <a:xfrm>
-            <a:off x="457200" y="1097280"/>
-            <a:ext cx="5349240" cy="365760"/>
+            <a:off x="5623559" y="1097280"/>
+            <a:ext cx="6080760" cy="365760"/>
           </a:xfrm>
           <a:prstGeom prst="rect">
             <a:avLst/>
@@ -14742,27 +14848,27 @@
           <a:p>
             <a:pPr algn="l"/>
             <a:r>
-              <a:rPr sz="1600" b="1" i="0">
-                <a:solidFill>
-                  <a:srgbClr val="40E0D0"/>
+              <a:rPr sz="1400" b="1" i="0">
+                <a:solidFill>
+                  <a:srgbClr val="FF1493"/>
                 </a:solidFill>
                 <a:latin typeface="Geist Mono"/>
               </a:rPr>
-              <a:t>FOUNDATIONS &amp; DATA</a:t>
-            </a:r>
-          </a:p>
-        </p:txBody>
-      </p:sp>
-      <p:sp>
-        <p:nvSpPr>
-          <p:cNvPr id="8" name="TextBox 7"/>
+              <a:t>THE REAL EQUITY QUESTION</a:t>
+            </a:r>
+          </a:p>
+        </p:txBody>
+      </p:sp>
+      <p:sp>
+        <p:nvSpPr>
+          <p:cNvPr id="9" name="TextBox 8"/>
           <p:cNvSpPr txBox="1"/>
           <p:nvPr/>
         </p:nvSpPr>
         <p:spPr>
           <a:xfrm>
-            <a:off x="457200" y="1600200"/>
-            <a:ext cx="5349240" cy="4571999"/>
+            <a:off x="5623559" y="1463040"/>
+            <a:ext cx="6080760" cy="822960"/>
           </a:xfrm>
           <a:prstGeom prst="rect">
             <a:avLst/>
@@ -14777,30 +14883,27 @@
           <a:p>
             <a:pPr algn="l"/>
             <a:r>
-              <a:rPr sz="1450" b="0" i="0">
+              <a:rPr sz="1500" b="0" i="0">
                 <a:solidFill>
                   <a:srgbClr val="14141C"/>
                 </a:solidFill>
                 <a:latin typeface="Geist"/>
               </a:rPr>
-              <a:t>[1] Doench et al. 2016, Nat Biotechnol -- Rule Set 2 / Azimuth, and the dataset we use.
-[2] Doench et al. 2014, Nat Biotechnol -- Rule Set 1: position + PAM predict cutting.
-[3] Hsu, Lander &amp; Zhang 2014, Cell -- how Cas9 is steered to a DNA site (the seed).
-[4] Zheng et al. 2017, Sci Rep -- direct evidence the PAM-proximal seed matters most.</a:t>
-            </a:r>
-          </a:p>
-        </p:txBody>
-      </p:sp>
-      <p:sp>
-        <p:nvSpPr>
-          <p:cNvPr id="9" name="TextBox 8"/>
+              <a:t>Our data is guide sequences -- no patients -- so per-guide fairness does not apply. The real equity issue in genome editing sits one step up.</a:t>
+            </a:r>
+          </a:p>
+        </p:txBody>
+      </p:sp>
+      <p:sp>
+        <p:nvSpPr>
+          <p:cNvPr id="10" name="TextBox 9"/>
           <p:cNvSpPr txBox="1"/>
           <p:nvPr/>
         </p:nvSpPr>
         <p:spPr>
           <a:xfrm>
-            <a:off x="6355080" y="1097280"/>
-            <a:ext cx="5349240" cy="365760"/>
+            <a:off x="5623559" y="2286000"/>
+            <a:ext cx="6080760" cy="292608"/>
           </a:xfrm>
           <a:prstGeom prst="rect">
             <a:avLst/>
@@ -14815,27 +14918,27 @@
           <a:p>
             <a:pPr algn="l"/>
             <a:r>
-              <a:rPr sz="1600" b="1" i="0">
-                <a:solidFill>
-                  <a:srgbClr val="FF1493"/>
+              <a:rPr sz="1250" b="1" i="0">
+                <a:solidFill>
+                  <a:srgbClr val="40E0D0"/>
                 </a:solidFill>
                 <a:latin typeface="Geist Mono"/>
               </a:rPr>
-              <a:t>METHODS &amp; REVIEWS</a:t>
-            </a:r>
-          </a:p>
-        </p:txBody>
-      </p:sp>
-      <p:sp>
-        <p:nvSpPr>
-          <p:cNvPr id="10" name="TextBox 9"/>
+              <a:t>THE MECHANISM</a:t>
+            </a:r>
+          </a:p>
+        </p:txBody>
+      </p:sp>
+      <p:sp>
+        <p:nvSpPr>
+          <p:cNvPr id="11" name="TextBox 10"/>
           <p:cNvSpPr txBox="1"/>
           <p:nvPr/>
         </p:nvSpPr>
         <p:spPr>
           <a:xfrm>
-            <a:off x="6355080" y="1600200"/>
-            <a:ext cx="5349240" cy="4571999"/>
+            <a:off x="5623559" y="2606040"/>
+            <a:ext cx="6080760" cy="1508760"/>
           </a:xfrm>
           <a:prstGeom prst="rect">
             <a:avLst/>
@@ -14850,16 +14953,197 @@
           <a:p>
             <a:pPr algn="l"/>
             <a:r>
-              <a:rPr sz="1450" b="0" i="0">
+              <a:rPr sz="1350" b="0" i="0">
                 <a:solidFill>
                   <a:srgbClr val="14141C"/>
                 </a:solidFill>
                 <a:latin typeface="Geist"/>
               </a:rPr>
-              <a:t>[5] Chuai et al. 2018, Genome Biol -- DeepCRISPR: deep learning for guide design.
-[6] Kim et al. 2019, Sci Adv -- DeepSpCas9: more data + neural nets push accuracy further.
-[7] Konstantakos et al. 2022, NAR -- a survey of guide-efficiency predictors.
-[8] Abbaszadeh &amp; Shahlai 2025, arXiv -- explainable AI + off-target safety.</a:t>
+              <a:t>Reference genomes and variant databases skew heavily European. A variant common in some ancestries but absent from the reference can sit under the guide or PAM -- a mismatch, an altered PAM, or a new off-target site -- so the same guide may cut less well, or less safely, for those patients.</a:t>
+            </a:r>
+          </a:p>
+        </p:txBody>
+      </p:sp>
+      <p:sp>
+        <p:nvSpPr>
+          <p:cNvPr id="12" name="TextBox 11"/>
+          <p:cNvSpPr txBox="1"/>
+          <p:nvPr/>
+        </p:nvSpPr>
+        <p:spPr>
+          <a:xfrm>
+            <a:off x="5623559" y="4160520"/>
+            <a:ext cx="6080760" cy="292608"/>
+          </a:xfrm>
+          <a:prstGeom prst="rect">
+            <a:avLst/>
+          </a:prstGeom>
+          <a:noFill/>
+        </p:spPr>
+        <p:txBody>
+          <a:bodyPr wrap="square" anchor="t" lIns="0" rIns="0" tIns="0" bIns="0">
+            <a:spAutoFit/>
+          </a:bodyPr>
+          <a:lstStyle/>
+          <a:p>
+            <a:pPr algn="l"/>
+            <a:r>
+              <a:rPr sz="1250" b="1" i="0">
+                <a:solidFill>
+                  <a:srgbClr val="8A2BE2"/>
+                </a:solidFill>
+                <a:latin typeface="Geist Mono"/>
+              </a:rPr>
+              <a:t>THE DATA THAT COULD CHECK IT</a:t>
+            </a:r>
+          </a:p>
+        </p:txBody>
+      </p:sp>
+      <p:sp>
+        <p:nvSpPr>
+          <p:cNvPr id="13" name="TextBox 12"/>
+          <p:cNvSpPr txBox="1"/>
+          <p:nvPr/>
+        </p:nvSpPr>
+        <p:spPr>
+          <a:xfrm>
+            <a:off x="5623559" y="4480560"/>
+            <a:ext cx="6080760" cy="777240"/>
+          </a:xfrm>
+          <a:prstGeom prst="rect">
+            <a:avLst/>
+          </a:prstGeom>
+          <a:noFill/>
+        </p:spPr>
+        <p:txBody>
+          <a:bodyPr wrap="square" anchor="t" lIns="0" rIns="0" tIns="0" bIns="0">
+            <a:spAutoFit/>
+          </a:bodyPr>
+          <a:lstStyle/>
+          <a:p>
+            <a:pPr algn="l"/>
+            <a:r>
+              <a:rPr sz="1350" b="0" i="0">
+                <a:solidFill>
+                  <a:srgbClr val="14141C"/>
+                </a:solidFill>
+                <a:latin typeface="Geist"/>
+              </a:rPr>
+              <a:t>gnomAD and 1000 Genomes hold ancestry-labeled variant frequencies -- the raw material to flag risky guides before the lab.</a:t>
+            </a:r>
+          </a:p>
+        </p:txBody>
+      </p:sp>
+      <p:sp>
+        <p:nvSpPr>
+          <p:cNvPr id="14" name="Rectangle 13"/>
+          <p:cNvSpPr/>
+          <p:nvPr/>
+        </p:nvSpPr>
+        <p:spPr>
+          <a:xfrm>
+            <a:off x="457200" y="5532120"/>
+            <a:ext cx="11247120" cy="41148"/>
+          </a:xfrm>
+          <a:prstGeom prst="rect">
+            <a:avLst/>
+          </a:prstGeom>
+          <a:solidFill>
+            <a:srgbClr val="F0C840"/>
+          </a:solidFill>
+          <a:ln>
+            <a:noFill/>
+          </a:ln>
+          <a:effectLst/>
+        </p:spPr>
+        <p:style>
+          <a:lnRef idx="1">
+            <a:schemeClr val="accent1"/>
+          </a:lnRef>
+          <a:fillRef idx="3">
+            <a:schemeClr val="accent1"/>
+          </a:fillRef>
+          <a:effectRef idx="2">
+            <a:schemeClr val="accent1"/>
+          </a:effectRef>
+          <a:fontRef idx="minor">
+            <a:schemeClr val="lt1"/>
+          </a:fontRef>
+        </p:style>
+        <p:txBody>
+          <a:bodyPr rtlCol="0" anchor="ctr"/>
+          <a:lstStyle/>
+          <a:p>
+            <a:pPr algn="ctr"/>
+          </a:p>
+        </p:txBody>
+      </p:sp>
+      <p:sp>
+        <p:nvSpPr>
+          <p:cNvPr id="15" name="TextBox 14"/>
+          <p:cNvSpPr txBox="1"/>
+          <p:nvPr/>
+        </p:nvSpPr>
+        <p:spPr>
+          <a:xfrm>
+            <a:off x="457200" y="5660136"/>
+            <a:ext cx="5394960" cy="640080"/>
+          </a:xfrm>
+          <a:prstGeom prst="rect">
+            <a:avLst/>
+          </a:prstGeom>
+          <a:noFill/>
+        </p:spPr>
+        <p:txBody>
+          <a:bodyPr wrap="square" anchor="t" lIns="0" rIns="0" tIns="0" bIns="0">
+            <a:spAutoFit/>
+          </a:bodyPr>
+          <a:lstStyle/>
+          <a:p>
+            <a:pPr algn="l"/>
+            <a:r>
+              <a:rPr sz="1250" b="0" i="0">
+                <a:solidFill>
+                  <a:srgbClr val="14141C"/>
+                </a:solidFill>
+                <a:latin typeface="Geist"/>
+              </a:rPr>
+              <a:t>[9] Popejoy &amp; Fullerton 2016, Nature -- "Genomics is failing on diversity."</a:t>
+            </a:r>
+          </a:p>
+        </p:txBody>
+      </p:sp>
+      <p:sp>
+        <p:nvSpPr>
+          <p:cNvPr id="16" name="TextBox 15"/>
+          <p:cNvSpPr txBox="1"/>
+          <p:nvPr/>
+        </p:nvSpPr>
+        <p:spPr>
+          <a:xfrm>
+            <a:off x="6309360" y="5660136"/>
+            <a:ext cx="5394960" cy="640080"/>
+          </a:xfrm>
+          <a:prstGeom prst="rect">
+            <a:avLst/>
+          </a:prstGeom>
+          <a:noFill/>
+        </p:spPr>
+        <p:txBody>
+          <a:bodyPr wrap="square" anchor="t" lIns="0" rIns="0" tIns="0" bIns="0">
+            <a:spAutoFit/>
+          </a:bodyPr>
+          <a:lstStyle/>
+          <a:p>
+            <a:pPr algn="l"/>
+            <a:r>
+              <a:rPr sz="1250" b="0" i="0">
+                <a:solidFill>
+                  <a:srgbClr val="14141C"/>
+                </a:solidFill>
+                <a:latin typeface="Geist"/>
+              </a:rPr>
+              <a:t>[10] Sirugo, Williams &amp; Tishkoff 2019, Cell -- "The Missing Diversity in Human Genetic Studies."</a:t>
             </a:r>
           </a:p>
         </p:txBody>
@@ -15000,7 +15284,7 @@
                 </a:solidFill>
                 <a:latin typeface="Geist Mono"/>
               </a:rPr>
-              <a:t>The honest bottom line</a:t>
+              <a:t>References</a:t>
             </a:r>
           </a:p>
         </p:txBody>
@@ -15092,8 +15376,8 @@
         </p:nvSpPr>
         <p:spPr>
           <a:xfrm>
-            <a:off x="914400" y="2198217"/>
-            <a:ext cx="10332720" cy="1280160"/>
+            <a:off x="457200" y="1097280"/>
+            <a:ext cx="5349240" cy="365760"/>
           </a:xfrm>
           <a:prstGeom prst="rect">
             <a:avLst/>
@@ -15106,35 +15390,146 @@
           </a:bodyPr>
           <a:lstStyle/>
           <a:p>
-            <a:pPr algn="ctr"/>
-            <a:r>
-              <a:rPr sz="3000" b="1" i="0">
+            <a:pPr algn="l"/>
+            <a:r>
+              <a:rPr sz="1600" b="1" i="0">
                 <a:solidFill>
                   <a:srgbClr val="40E0D0"/>
                 </a:solidFill>
                 <a:latin typeface="Geist Mono"/>
               </a:rPr>
-              <a:t>A guide-picker earns its keep by shortlisting the winners -- and explaining itself.</a:t>
-            </a:r>
-          </a:p>
-        </p:txBody>
-      </p:sp>
-      <p:sp>
-        <p:nvSpPr>
-          <p:cNvPr id="8" name="Rectangle 7"/>
+              <a:t>FOUNDATIONS &amp; DATA</a:t>
+            </a:r>
+          </a:p>
+        </p:txBody>
+      </p:sp>
+      <p:sp>
+        <p:nvSpPr>
+          <p:cNvPr id="8" name="TextBox 7"/>
+          <p:cNvSpPr txBox="1"/>
+          <p:nvPr/>
+        </p:nvSpPr>
+        <p:spPr>
+          <a:xfrm>
+            <a:off x="457200" y="1600200"/>
+            <a:ext cx="5349240" cy="3977639"/>
+          </a:xfrm>
+          <a:prstGeom prst="rect">
+            <a:avLst/>
+          </a:prstGeom>
+          <a:noFill/>
+        </p:spPr>
+        <p:txBody>
+          <a:bodyPr wrap="square" anchor="t" lIns="0" rIns="0" tIns="0" bIns="0">
+            <a:spAutoFit/>
+          </a:bodyPr>
+          <a:lstStyle/>
+          <a:p>
+            <a:pPr algn="l"/>
+            <a:r>
+              <a:rPr sz="1400" b="0" i="0">
+                <a:solidFill>
+                  <a:srgbClr val="14141C"/>
+                </a:solidFill>
+                <a:latin typeface="Geist"/>
+              </a:rPr>
+              <a:t>[1] Doench et al. 2016, Nat Biotechnol -- Rule Set 2 / Azimuth, and the dataset we use.
+[2] Doench et al. 2014, Nat Biotechnol -- Rule Set 1: position + PAM predict cutting.
+[3] Hsu, Lander &amp; Zhang 2014, Cell -- how Cas9 is steered to a DNA site (the seed).
+[4] Zheng et al. 2017, Sci Rep -- direct evidence the PAM-proximal seed matters most.</a:t>
+            </a:r>
+          </a:p>
+        </p:txBody>
+      </p:sp>
+      <p:sp>
+        <p:nvSpPr>
+          <p:cNvPr id="9" name="TextBox 8"/>
+          <p:cNvSpPr txBox="1"/>
+          <p:nvPr/>
+        </p:nvSpPr>
+        <p:spPr>
+          <a:xfrm>
+            <a:off x="6355080" y="1097280"/>
+            <a:ext cx="5349240" cy="365760"/>
+          </a:xfrm>
+          <a:prstGeom prst="rect">
+            <a:avLst/>
+          </a:prstGeom>
+          <a:noFill/>
+        </p:spPr>
+        <p:txBody>
+          <a:bodyPr wrap="square" anchor="t" lIns="0" rIns="0" tIns="0" bIns="0">
+            <a:spAutoFit/>
+          </a:bodyPr>
+          <a:lstStyle/>
+          <a:p>
+            <a:pPr algn="l"/>
+            <a:r>
+              <a:rPr sz="1600" b="1" i="0">
+                <a:solidFill>
+                  <a:srgbClr val="FF1493"/>
+                </a:solidFill>
+                <a:latin typeface="Geist Mono"/>
+              </a:rPr>
+              <a:t>METHODS &amp; REVIEWS</a:t>
+            </a:r>
+          </a:p>
+        </p:txBody>
+      </p:sp>
+      <p:sp>
+        <p:nvSpPr>
+          <p:cNvPr id="10" name="TextBox 9"/>
+          <p:cNvSpPr txBox="1"/>
+          <p:nvPr/>
+        </p:nvSpPr>
+        <p:spPr>
+          <a:xfrm>
+            <a:off x="6355080" y="1600200"/>
+            <a:ext cx="5349240" cy="3977639"/>
+          </a:xfrm>
+          <a:prstGeom prst="rect">
+            <a:avLst/>
+          </a:prstGeom>
+          <a:noFill/>
+        </p:spPr>
+        <p:txBody>
+          <a:bodyPr wrap="square" anchor="t" lIns="0" rIns="0" tIns="0" bIns="0">
+            <a:spAutoFit/>
+          </a:bodyPr>
+          <a:lstStyle/>
+          <a:p>
+            <a:pPr algn="l"/>
+            <a:r>
+              <a:rPr sz="1400" b="0" i="0">
+                <a:solidFill>
+                  <a:srgbClr val="14141C"/>
+                </a:solidFill>
+                <a:latin typeface="Geist"/>
+              </a:rPr>
+              <a:t>[5] Chuai et al. 2018, Genome Biol -- DeepCRISPR: deep learning for guide design.
+[6] Kim et al. 2019, Sci Adv -- DeepSpCas9: more data + neural nets push accuracy further.
+[7] Konstantakos et al. 2022, NAR -- a survey of guide-efficiency predictors.
+[8] Abbaszadeh &amp; Shahlai 2025, arXiv -- explainable AI + off-target safety.</a:t>
+            </a:r>
+          </a:p>
+        </p:txBody>
+      </p:sp>
+      <p:sp>
+        <p:nvSpPr>
+          <p:cNvPr id="11" name="Rectangle 10"/>
           <p:cNvSpPr/>
           <p:nvPr/>
         </p:nvSpPr>
         <p:spPr>
           <a:xfrm>
-            <a:off x="4983480" y="3615537"/>
-            <a:ext cx="2194560" cy="45720"/>
+            <a:off x="457200" y="5166359"/>
+            <a:ext cx="11247120" cy="41148"/>
           </a:xfrm>
           <a:prstGeom prst="rect">
             <a:avLst/>
           </a:prstGeom>
           <a:solidFill>
-            <a:srgbClr val="40E0D0"/>
+            <a:srgbClr val="F0C840"/>
           </a:solidFill>
           <a:ln>
             <a:noFill/>
@@ -15165,14 +15560,14 @@
       </p:sp>
       <p:sp>
         <p:nvSpPr>
-          <p:cNvPr id="9" name="TextBox 8"/>
+          <p:cNvPr id="12" name="TextBox 11"/>
           <p:cNvSpPr txBox="1"/>
           <p:nvPr/>
         </p:nvSpPr>
         <p:spPr>
           <a:xfrm>
-            <a:off x="1371600" y="4072737"/>
-            <a:ext cx="9418320" cy="1097280"/>
+            <a:off x="457200" y="5276088"/>
+            <a:ext cx="11247120" cy="320040"/>
           </a:xfrm>
           <a:prstGeom prst="rect">
             <a:avLst/>
@@ -15185,15 +15580,50 @@
           </a:bodyPr>
           <a:lstStyle/>
           <a:p>
-            <a:pPr algn="ctr"/>
-            <a:r>
-              <a:rPr sz="1900" b="0" i="0">
+            <a:pPr algn="l"/>
+            <a:r>
+              <a:rPr sz="1400" b="1" i="0">
+                <a:solidFill>
+                  <a:srgbClr val="9C7108"/>
+                </a:solidFill>
+                <a:latin typeface="Geist Mono"/>
+              </a:rPr>
+              <a:t>EQUITY &amp; DIVERSITY IN GENOMICS</a:t>
+            </a:r>
+          </a:p>
+        </p:txBody>
+      </p:sp>
+      <p:sp>
+        <p:nvSpPr>
+          <p:cNvPr id="13" name="TextBox 12"/>
+          <p:cNvSpPr txBox="1"/>
+          <p:nvPr/>
+        </p:nvSpPr>
+        <p:spPr>
+          <a:xfrm>
+            <a:off x="457200" y="5623559"/>
+            <a:ext cx="11247120" cy="548640"/>
+          </a:xfrm>
+          <a:prstGeom prst="rect">
+            <a:avLst/>
+          </a:prstGeom>
+          <a:noFill/>
+        </p:spPr>
+        <p:txBody>
+          <a:bodyPr wrap="square" anchor="t" lIns="0" rIns="0" tIns="0" bIns="0">
+            <a:spAutoFit/>
+          </a:bodyPr>
+          <a:lstStyle/>
+          <a:p>
+            <a:pPr algn="l"/>
+            <a:r>
+              <a:rPr sz="1300" b="0" i="0">
                 <a:solidFill>
                   <a:srgbClr val="14141C"/>
                 </a:solidFill>
                 <a:latin typeface="Geist"/>
               </a:rPr>
-              <a:t>Use it to build intuition and narrow the field -- then use a validated tool and the lab to actually choose and confirm a guide.</a:t>
+              <a:t>[9] Popejoy &amp; Fullerton 2016, Nature -- "Genomics is failing on diversity."     [10] Sirugo, Williams &amp; Tishkoff 2019, Cell -- "The Missing Diversity in Human Genetic Studies."</a:t>
             </a:r>
           </a:p>
         </p:txBody>
@@ -15207,6 +15637,340 @@
 </file>
 
 <file path=ppt/slides/slide23.xml><?xml version="1.0" encoding="utf-8"?>
+<p:sld xmlns:a="http://schemas.openxmlformats.org/drawingml/2006/main" xmlns:p="http://schemas.openxmlformats.org/presentationml/2006/main" xmlns:r="http://schemas.openxmlformats.org/officeDocument/2006/relationships">
+  <p:cSld>
+    <p:spTree>
+      <p:nvGrpSpPr>
+        <p:cNvPr id="1" name=""/>
+        <p:cNvGrpSpPr/>
+        <p:nvPr/>
+      </p:nvGrpSpPr>
+      <p:grpSpPr/>
+      <p:sp>
+        <p:nvSpPr>
+          <p:cNvPr id="2" name="Rectangle 1"/>
+          <p:cNvSpPr/>
+          <p:nvPr/>
+        </p:nvSpPr>
+        <p:spPr>
+          <a:xfrm>
+            <a:off x="0" y="0"/>
+            <a:ext cx="12191695" cy="6858000"/>
+          </a:xfrm>
+          <a:prstGeom prst="rect">
+            <a:avLst/>
+          </a:prstGeom>
+          <a:solidFill>
+            <a:srgbClr val="F6F4EE"/>
+          </a:solidFill>
+          <a:ln>
+            <a:noFill/>
+          </a:ln>
+          <a:effectLst/>
+        </p:spPr>
+        <p:style>
+          <a:lnRef idx="1">
+            <a:schemeClr val="accent1"/>
+          </a:lnRef>
+          <a:fillRef idx="3">
+            <a:schemeClr val="accent1"/>
+          </a:fillRef>
+          <a:effectRef idx="2">
+            <a:schemeClr val="accent1"/>
+          </a:effectRef>
+          <a:fontRef idx="minor">
+            <a:schemeClr val="lt1"/>
+          </a:fontRef>
+        </p:style>
+        <p:txBody>
+          <a:bodyPr rtlCol="0" anchor="ctr"/>
+          <a:lstStyle/>
+          <a:p>
+            <a:pPr algn="ctr"/>
+          </a:p>
+        </p:txBody>
+      </p:sp>
+      <p:sp>
+        <p:nvSpPr>
+          <p:cNvPr id="3" name="Rectangle 2"/>
+          <p:cNvSpPr/>
+          <p:nvPr/>
+        </p:nvSpPr>
+        <p:spPr>
+          <a:xfrm>
+            <a:off x="0" y="0"/>
+            <a:ext cx="201168" cy="6858000"/>
+          </a:xfrm>
+          <a:prstGeom prst="rect">
+            <a:avLst/>
+          </a:prstGeom>
+          <a:solidFill>
+            <a:srgbClr val="40E0D0"/>
+          </a:solidFill>
+          <a:ln>
+            <a:noFill/>
+          </a:ln>
+          <a:effectLst/>
+        </p:spPr>
+        <p:style>
+          <a:lnRef idx="1">
+            <a:schemeClr val="accent1"/>
+          </a:lnRef>
+          <a:fillRef idx="3">
+            <a:schemeClr val="accent1"/>
+          </a:fillRef>
+          <a:effectRef idx="2">
+            <a:schemeClr val="accent1"/>
+          </a:effectRef>
+          <a:fontRef idx="minor">
+            <a:schemeClr val="lt1"/>
+          </a:fontRef>
+        </p:style>
+        <p:txBody>
+          <a:bodyPr rtlCol="0" anchor="ctr"/>
+          <a:lstStyle/>
+          <a:p>
+            <a:pPr algn="ctr"/>
+          </a:p>
+        </p:txBody>
+      </p:sp>
+      <p:sp>
+        <p:nvSpPr>
+          <p:cNvPr id="4" name="TextBox 3"/>
+          <p:cNvSpPr txBox="1"/>
+          <p:nvPr/>
+        </p:nvSpPr>
+        <p:spPr>
+          <a:xfrm>
+            <a:off x="457200" y="274320"/>
+            <a:ext cx="11247120" cy="502920"/>
+          </a:xfrm>
+          <a:prstGeom prst="rect">
+            <a:avLst/>
+          </a:prstGeom>
+          <a:noFill/>
+        </p:spPr>
+        <p:txBody>
+          <a:bodyPr wrap="square" anchor="t" lIns="0" rIns="0" tIns="0" bIns="0">
+            <a:spAutoFit/>
+          </a:bodyPr>
+          <a:lstStyle/>
+          <a:p>
+            <a:pPr algn="l"/>
+            <a:r>
+              <a:rPr sz="2800" b="1" i="0">
+                <a:solidFill>
+                  <a:srgbClr val="14141C"/>
+                </a:solidFill>
+                <a:latin typeface="Geist Mono"/>
+              </a:rPr>
+              <a:t>The honest bottom line</a:t>
+            </a:r>
+          </a:p>
+        </p:txBody>
+      </p:sp>
+      <p:sp>
+        <p:nvSpPr>
+          <p:cNvPr id="5" name="Rectangle 4"/>
+          <p:cNvSpPr/>
+          <p:nvPr/>
+        </p:nvSpPr>
+        <p:spPr>
+          <a:xfrm>
+            <a:off x="457200" y="868680"/>
+            <a:ext cx="11247120" cy="4572"/>
+          </a:xfrm>
+          <a:prstGeom prst="rect">
+            <a:avLst/>
+          </a:prstGeom>
+          <a:solidFill>
+            <a:srgbClr val="DDDDDD"/>
+          </a:solidFill>
+          <a:ln>
+            <a:noFill/>
+          </a:ln>
+          <a:effectLst/>
+        </p:spPr>
+        <p:style>
+          <a:lnRef idx="1">
+            <a:schemeClr val="accent1"/>
+          </a:lnRef>
+          <a:fillRef idx="3">
+            <a:schemeClr val="accent1"/>
+          </a:fillRef>
+          <a:effectRef idx="2">
+            <a:schemeClr val="accent1"/>
+          </a:effectRef>
+          <a:fontRef idx="minor">
+            <a:schemeClr val="lt1"/>
+          </a:fontRef>
+        </p:style>
+        <p:txBody>
+          <a:bodyPr rtlCol="0" anchor="ctr"/>
+          <a:lstStyle/>
+          <a:p>
+            <a:pPr algn="ctr"/>
+          </a:p>
+        </p:txBody>
+      </p:sp>
+      <p:sp>
+        <p:nvSpPr>
+          <p:cNvPr id="6" name="TextBox 5"/>
+          <p:cNvSpPr txBox="1"/>
+          <p:nvPr/>
+        </p:nvSpPr>
+        <p:spPr>
+          <a:xfrm>
+            <a:off x="457200" y="6510528"/>
+            <a:ext cx="11247120" cy="274320"/>
+          </a:xfrm>
+          <a:prstGeom prst="rect">
+            <a:avLst/>
+          </a:prstGeom>
+          <a:noFill/>
+        </p:spPr>
+        <p:txBody>
+          <a:bodyPr wrap="square" anchor="t" lIns="0" rIns="0" tIns="0" bIns="0">
+            <a:spAutoFit/>
+          </a:bodyPr>
+          <a:lstStyle/>
+          <a:p>
+            <a:pPr algn="l"/>
+            <a:r>
+              <a:rPr sz="900" b="0" i="0">
+                <a:solidFill>
+                  <a:srgbClr val="555560"/>
+                </a:solidFill>
+                <a:latin typeface="Geist Mono"/>
+              </a:rPr>
+              <a:t>Jinchi Wei  ·  Outset  ·  Picking good CRISPR guides before the lab  ·  2026-07-08</a:t>
+            </a:r>
+          </a:p>
+        </p:txBody>
+      </p:sp>
+      <p:sp>
+        <p:nvSpPr>
+          <p:cNvPr id="7" name="TextBox 6"/>
+          <p:cNvSpPr txBox="1"/>
+          <p:nvPr/>
+        </p:nvSpPr>
+        <p:spPr>
+          <a:xfrm>
+            <a:off x="914400" y="2198217"/>
+            <a:ext cx="10332720" cy="1280160"/>
+          </a:xfrm>
+          <a:prstGeom prst="rect">
+            <a:avLst/>
+          </a:prstGeom>
+          <a:noFill/>
+        </p:spPr>
+        <p:txBody>
+          <a:bodyPr wrap="square" anchor="t" lIns="0" rIns="0" tIns="0" bIns="0">
+            <a:spAutoFit/>
+          </a:bodyPr>
+          <a:lstStyle/>
+          <a:p>
+            <a:pPr algn="ctr"/>
+            <a:r>
+              <a:rPr sz="3000" b="1" i="0">
+                <a:solidFill>
+                  <a:srgbClr val="40E0D0"/>
+                </a:solidFill>
+                <a:latin typeface="Geist Mono"/>
+              </a:rPr>
+              <a:t>A guide-picker earns its keep by shortlisting the winners -- and explaining itself.</a:t>
+            </a:r>
+          </a:p>
+        </p:txBody>
+      </p:sp>
+      <p:sp>
+        <p:nvSpPr>
+          <p:cNvPr id="8" name="Rectangle 7"/>
+          <p:cNvSpPr/>
+          <p:nvPr/>
+        </p:nvSpPr>
+        <p:spPr>
+          <a:xfrm>
+            <a:off x="4983480" y="3615537"/>
+            <a:ext cx="2194560" cy="45720"/>
+          </a:xfrm>
+          <a:prstGeom prst="rect">
+            <a:avLst/>
+          </a:prstGeom>
+          <a:solidFill>
+            <a:srgbClr val="40E0D0"/>
+          </a:solidFill>
+          <a:ln>
+            <a:noFill/>
+          </a:ln>
+          <a:effectLst/>
+        </p:spPr>
+        <p:style>
+          <a:lnRef idx="1">
+            <a:schemeClr val="accent1"/>
+          </a:lnRef>
+          <a:fillRef idx="3">
+            <a:schemeClr val="accent1"/>
+          </a:fillRef>
+          <a:effectRef idx="2">
+            <a:schemeClr val="accent1"/>
+          </a:effectRef>
+          <a:fontRef idx="minor">
+            <a:schemeClr val="lt1"/>
+          </a:fontRef>
+        </p:style>
+        <p:txBody>
+          <a:bodyPr rtlCol="0" anchor="ctr"/>
+          <a:lstStyle/>
+          <a:p>
+            <a:pPr algn="ctr"/>
+          </a:p>
+        </p:txBody>
+      </p:sp>
+      <p:sp>
+        <p:nvSpPr>
+          <p:cNvPr id="9" name="TextBox 8"/>
+          <p:cNvSpPr txBox="1"/>
+          <p:nvPr/>
+        </p:nvSpPr>
+        <p:spPr>
+          <a:xfrm>
+            <a:off x="1371600" y="4072737"/>
+            <a:ext cx="9418320" cy="1097280"/>
+          </a:xfrm>
+          <a:prstGeom prst="rect">
+            <a:avLst/>
+          </a:prstGeom>
+          <a:noFill/>
+        </p:spPr>
+        <p:txBody>
+          <a:bodyPr wrap="square" anchor="t" lIns="0" rIns="0" tIns="0" bIns="0">
+            <a:spAutoFit/>
+          </a:bodyPr>
+          <a:lstStyle/>
+          <a:p>
+            <a:pPr algn="ctr"/>
+            <a:r>
+              <a:rPr sz="1900" b="0" i="0">
+                <a:solidFill>
+                  <a:srgbClr val="14141C"/>
+                </a:solidFill>
+                <a:latin typeface="Geist"/>
+              </a:rPr>
+              <a:t>Use it to build intuition and narrow the field -- then use a validated tool and the lab to actually choose and confirm a guide.</a:t>
+            </a:r>
+          </a:p>
+        </p:txBody>
+      </p:sp>
+    </p:spTree>
+  </p:cSld>
+  <p:clrMapOvr>
+    <a:masterClrMapping/>
+  </p:clrMapOvr>
+</p:sld>
+</file>
+
+<file path=ppt/slides/slide24.xml><?xml version="1.0" encoding="utf-8"?>
 <p:sld xmlns:a="http://schemas.openxmlformats.org/drawingml/2006/main" xmlns:p="http://schemas.openxmlformats.org/presentationml/2006/main" xmlns:r="http://schemas.openxmlformats.org/officeDocument/2006/relationships">
   <p:cSld>
     <p:bg>

</xml_diff>